<commit_message>
Deploy from DevStart-Hub/DevStart@4f0a804 [2025-11-06 13:27:08 UTC]
</commit_message>
<xml_diff>
--- a/resources/GettingStartedWithDevStart/FlowchartPython.pptx
+++ b/resources/GettingStartedWithDevStart/FlowchartPython.pptx
@@ -115,13 +115,45 @@
 <file path=ppt/revisionInfo.xml><?xml version="1.0" encoding="utf-8"?>
 <p1510:revInfo xmlns:a="http://schemas.openxmlformats.org/drawingml/2006/main" xmlns:r="http://schemas.openxmlformats.org/officeDocument/2006/relationships" xmlns:p1510="http://schemas.microsoft.com/office/powerpoint/2015/10/main">
   <p1510:revLst>
-    <p1510:client id="{0D36F859-059A-4DB7-AEC5-974ED1AC50D6}" v="30" dt="2025-08-30T21:32:19.922"/>
+    <p1510:client id="{8C45673E-85D5-43D5-9FAE-AAFDE0DDE4CB}" v="1" dt="2025-11-06T10:42:18.804"/>
   </p1510:revLst>
 </p1510:revInfo>
 </file>
 
 <file path=ppt/changesInfos/changesInfo1.xml><?xml version="1.0" encoding="utf-8"?>
 <pc:chgInfo xmlns:a="http://schemas.openxmlformats.org/drawingml/2006/main" xmlns:r="http://schemas.openxmlformats.org/officeDocument/2006/relationships" xmlns:ac="http://schemas.microsoft.com/office/drawing/2013/main/command" xmlns:pc="http://schemas.microsoft.com/office/powerpoint/2013/main/command">
+  <pc:docChgLst>
+    <pc:chgData name="Tommaso Ghilardi (Staff)" userId="b9591c49-3913-47aa-a516-44e0ea4248a4" providerId="ADAL" clId="{DC36FB0E-DC38-4EEF-9931-E787A9AA7CB8}"/>
+    <pc:docChg chg="modSld">
+      <pc:chgData name="Tommaso Ghilardi (Staff)" userId="b9591c49-3913-47aa-a516-44e0ea4248a4" providerId="ADAL" clId="{DC36FB0E-DC38-4EEF-9931-E787A9AA7CB8}" dt="2025-11-06T11:12:03.351" v="10" actId="20577"/>
+      <pc:docMkLst>
+        <pc:docMk/>
+      </pc:docMkLst>
+      <pc:sldChg chg="modSp mod">
+        <pc:chgData name="Tommaso Ghilardi (Staff)" userId="b9591c49-3913-47aa-a516-44e0ea4248a4" providerId="ADAL" clId="{DC36FB0E-DC38-4EEF-9931-E787A9AA7CB8}" dt="2025-11-06T11:12:03.351" v="10" actId="20577"/>
+        <pc:sldMkLst>
+          <pc:docMk/>
+          <pc:sldMk cId="473977692" sldId="260"/>
+        </pc:sldMkLst>
+        <pc:spChg chg="mod">
+          <ac:chgData name="Tommaso Ghilardi (Staff)" userId="b9591c49-3913-47aa-a516-44e0ea4248a4" providerId="ADAL" clId="{DC36FB0E-DC38-4EEF-9931-E787A9AA7CB8}" dt="2025-11-06T10:42:18.803" v="0"/>
+          <ac:spMkLst>
+            <pc:docMk/>
+            <pc:sldMk cId="473977692" sldId="260"/>
+            <ac:spMk id="3" creationId="{5A05495E-9357-E471-D091-454DB08C8488}"/>
+          </ac:spMkLst>
+        </pc:spChg>
+        <pc:spChg chg="mod">
+          <ac:chgData name="Tommaso Ghilardi (Staff)" userId="b9591c49-3913-47aa-a516-44e0ea4248a4" providerId="ADAL" clId="{DC36FB0E-DC38-4EEF-9931-E787A9AA7CB8}" dt="2025-11-06T11:12:03.351" v="10" actId="20577"/>
+          <ac:spMkLst>
+            <pc:docMk/>
+            <pc:sldMk cId="473977692" sldId="260"/>
+            <ac:spMk id="5" creationId="{20AEB75B-B2FD-C857-22F8-9B24B288EDDC}"/>
+          </ac:spMkLst>
+        </pc:spChg>
+      </pc:sldChg>
+    </pc:docChg>
+  </pc:docChgLst>
   <pc:docChgLst>
     <pc:chgData name="Tommaso Ghilardi (Staff)" userId="b9591c49-3913-47aa-a516-44e0ea4248a4" providerId="ADAL" clId="{0D36F859-059A-4DB7-AEC5-974ED1AC50D6}"/>
     <pc:docChg chg="undo custSel addSld delSld modSld">
@@ -135,38 +167,6 @@
           <pc:docMk/>
           <pc:sldMk cId="1204861259" sldId="259"/>
         </pc:sldMkLst>
-        <pc:spChg chg="del">
-          <ac:chgData name="Tommaso Ghilardi (Staff)" userId="b9591c49-3913-47aa-a516-44e0ea4248a4" providerId="ADAL" clId="{0D36F859-059A-4DB7-AEC5-974ED1AC50D6}" dt="2025-08-29T17:03:35.915" v="392" actId="478"/>
-          <ac:spMkLst>
-            <pc:docMk/>
-            <pc:sldMk cId="1204861259" sldId="259"/>
-            <ac:spMk id="2" creationId="{59FE5820-4E9E-A0B1-F1D5-2EEDB008C3B4}"/>
-          </ac:spMkLst>
-        </pc:spChg>
-        <pc:spChg chg="add del mod">
-          <ac:chgData name="Tommaso Ghilardi (Staff)" userId="b9591c49-3913-47aa-a516-44e0ea4248a4" providerId="ADAL" clId="{0D36F859-059A-4DB7-AEC5-974ED1AC50D6}" dt="2025-08-29T17:03:40.497" v="393" actId="478"/>
-          <ac:spMkLst>
-            <pc:docMk/>
-            <pc:sldMk cId="1204861259" sldId="259"/>
-            <ac:spMk id="9" creationId="{412EC709-34A2-A3B9-FAE4-54E870E7A650}"/>
-          </ac:spMkLst>
-        </pc:spChg>
-        <pc:picChg chg="add mod">
-          <ac:chgData name="Tommaso Ghilardi (Staff)" userId="b9591c49-3913-47aa-a516-44e0ea4248a4" providerId="ADAL" clId="{0D36F859-059A-4DB7-AEC5-974ED1AC50D6}" dt="2025-08-29T17:14:12.222" v="398" actId="1076"/>
-          <ac:picMkLst>
-            <pc:docMk/>
-            <pc:sldMk cId="1204861259" sldId="259"/>
-            <ac:picMk id="2" creationId="{E271A99D-7616-9B1E-2550-7E054E72026B}"/>
-          </ac:picMkLst>
-        </pc:picChg>
-        <pc:picChg chg="del mod">
-          <ac:chgData name="Tommaso Ghilardi (Staff)" userId="b9591c49-3913-47aa-a516-44e0ea4248a4" providerId="ADAL" clId="{0D36F859-059A-4DB7-AEC5-974ED1AC50D6}" dt="2025-08-29T17:03:26.398" v="391" actId="478"/>
-          <ac:picMkLst>
-            <pc:docMk/>
-            <pc:sldMk cId="1204861259" sldId="259"/>
-            <ac:picMk id="19" creationId="{BC084F83-2B7D-4036-2DCD-49AFF9BD8F45}"/>
-          </ac:picMkLst>
-        </pc:picChg>
       </pc:sldChg>
       <pc:sldChg chg="addSp delSp modSp add mod">
         <pc:chgData name="Tommaso Ghilardi (Staff)" userId="b9591c49-3913-47aa-a516-44e0ea4248a4" providerId="ADAL" clId="{0D36F859-059A-4DB7-AEC5-974ED1AC50D6}" dt="2025-08-30T21:32:19.922" v="750"/>
@@ -174,318 +174,6 @@
           <pc:docMk/>
           <pc:sldMk cId="473977692" sldId="260"/>
         </pc:sldMkLst>
-        <pc:spChg chg="add mod">
-          <ac:chgData name="Tommaso Ghilardi (Staff)" userId="b9591c49-3913-47aa-a516-44e0ea4248a4" providerId="ADAL" clId="{0D36F859-059A-4DB7-AEC5-974ED1AC50D6}" dt="2025-08-30T21:31:02.859" v="683" actId="1036"/>
-          <ac:spMkLst>
-            <pc:docMk/>
-            <pc:sldMk cId="473977692" sldId="260"/>
-            <ac:spMk id="2" creationId="{51ECF505-A488-5A1A-87F2-9AE71DFD7584}"/>
-          </ac:spMkLst>
-        </pc:spChg>
-        <pc:spChg chg="mod">
-          <ac:chgData name="Tommaso Ghilardi (Staff)" userId="b9591c49-3913-47aa-a516-44e0ea4248a4" providerId="ADAL" clId="{0D36F859-059A-4DB7-AEC5-974ED1AC50D6}" dt="2025-08-30T21:25:40.694" v="642"/>
-          <ac:spMkLst>
-            <pc:docMk/>
-            <pc:sldMk cId="473977692" sldId="260"/>
-            <ac:spMk id="3" creationId="{5A05495E-9357-E471-D091-454DB08C8488}"/>
-          </ac:spMkLst>
-        </pc:spChg>
-        <pc:spChg chg="mod">
-          <ac:chgData name="Tommaso Ghilardi (Staff)" userId="b9591c49-3913-47aa-a516-44e0ea4248a4" providerId="ADAL" clId="{0D36F859-059A-4DB7-AEC5-974ED1AC50D6}" dt="2025-08-30T11:40:22.461" v="570"/>
-          <ac:spMkLst>
-            <pc:docMk/>
-            <pc:sldMk cId="473977692" sldId="260"/>
-            <ac:spMk id="5" creationId="{20AEB75B-B2FD-C857-22F8-9B24B288EDDC}"/>
-          </ac:spMkLst>
-        </pc:spChg>
-        <pc:spChg chg="add mod">
-          <ac:chgData name="Tommaso Ghilardi (Staff)" userId="b9591c49-3913-47aa-a516-44e0ea4248a4" providerId="ADAL" clId="{0D36F859-059A-4DB7-AEC5-974ED1AC50D6}" dt="2025-08-30T11:40:07.465" v="569" actId="1036"/>
-          <ac:spMkLst>
-            <pc:docMk/>
-            <pc:sldMk cId="473977692" sldId="260"/>
-            <ac:spMk id="8" creationId="{D40E4F07-DA5F-5483-5D56-79FA12CA80DD}"/>
-          </ac:spMkLst>
-        </pc:spChg>
-        <pc:spChg chg="add mod">
-          <ac:chgData name="Tommaso Ghilardi (Staff)" userId="b9591c49-3913-47aa-a516-44e0ea4248a4" providerId="ADAL" clId="{0D36F859-059A-4DB7-AEC5-974ED1AC50D6}" dt="2025-08-30T11:38:54.206" v="530"/>
-          <ac:spMkLst>
-            <pc:docMk/>
-            <pc:sldMk cId="473977692" sldId="260"/>
-            <ac:spMk id="9" creationId="{C3735D68-DBEC-373C-4FB0-92692DDA0DED}"/>
-          </ac:spMkLst>
-        </pc:spChg>
-        <pc:spChg chg="add mod">
-          <ac:chgData name="Tommaso Ghilardi (Staff)" userId="b9591c49-3913-47aa-a516-44e0ea4248a4" providerId="ADAL" clId="{0D36F859-059A-4DB7-AEC5-974ED1AC50D6}" dt="2025-08-30T21:28:05.661" v="645"/>
-          <ac:spMkLst>
-            <pc:docMk/>
-            <pc:sldMk cId="473977692" sldId="260"/>
-            <ac:spMk id="15" creationId="{05A170F7-4CA5-62FF-3898-7B1B95B0C649}"/>
-          </ac:spMkLst>
-        </pc:spChg>
-        <pc:spChg chg="mod">
-          <ac:chgData name="Tommaso Ghilardi (Staff)" userId="b9591c49-3913-47aa-a516-44e0ea4248a4" providerId="ADAL" clId="{0D36F859-059A-4DB7-AEC5-974ED1AC50D6}" dt="2025-08-30T21:32:19.922" v="750"/>
-          <ac:spMkLst>
-            <pc:docMk/>
-            <pc:sldMk cId="473977692" sldId="260"/>
-            <ac:spMk id="30" creationId="{84017305-8577-D1BA-26A3-76934F4A6EC4}"/>
-          </ac:spMkLst>
-        </pc:spChg>
-        <pc:spChg chg="mod">
-          <ac:chgData name="Tommaso Ghilardi (Staff)" userId="b9591c49-3913-47aa-a516-44e0ea4248a4" providerId="ADAL" clId="{0D36F859-059A-4DB7-AEC5-974ED1AC50D6}" dt="2025-08-30T11:37:38.704" v="522" actId="1036"/>
-          <ac:spMkLst>
-            <pc:docMk/>
-            <pc:sldMk cId="473977692" sldId="260"/>
-            <ac:spMk id="59" creationId="{B3DF5393-782D-DD63-9DD9-4002101FD755}"/>
-          </ac:spMkLst>
-        </pc:spChg>
-        <pc:spChg chg="mod">
-          <ac:chgData name="Tommaso Ghilardi (Staff)" userId="b9591c49-3913-47aa-a516-44e0ea4248a4" providerId="ADAL" clId="{0D36F859-059A-4DB7-AEC5-974ED1AC50D6}" dt="2025-08-30T11:39:21.314" v="561" actId="14100"/>
-          <ac:spMkLst>
-            <pc:docMk/>
-            <pc:sldMk cId="473977692" sldId="260"/>
-            <ac:spMk id="103" creationId="{AB53003C-B479-D972-858A-998AF37B4D0B}"/>
-          </ac:spMkLst>
-        </pc:spChg>
-        <pc:spChg chg="mod">
-          <ac:chgData name="Tommaso Ghilardi (Staff)" userId="b9591c49-3913-47aa-a516-44e0ea4248a4" providerId="ADAL" clId="{0D36F859-059A-4DB7-AEC5-974ED1AC50D6}" dt="2025-08-30T21:23:38.144" v="639"/>
-          <ac:spMkLst>
-            <pc:docMk/>
-            <pc:sldMk cId="473977692" sldId="260"/>
-            <ac:spMk id="165" creationId="{00C224FC-1D30-946F-804F-F55EBA1105CA}"/>
-          </ac:spMkLst>
-        </pc:spChg>
-        <pc:spChg chg="mod">
-          <ac:chgData name="Tommaso Ghilardi (Staff)" userId="b9591c49-3913-47aa-a516-44e0ea4248a4" providerId="ADAL" clId="{0D36F859-059A-4DB7-AEC5-974ED1AC50D6}" dt="2025-08-30T21:24:20.968" v="640"/>
-          <ac:spMkLst>
-            <pc:docMk/>
-            <pc:sldMk cId="473977692" sldId="260"/>
-            <ac:spMk id="167" creationId="{58DDBD98-D8A8-54C2-A548-5B8991DF6103}"/>
-          </ac:spMkLst>
-        </pc:spChg>
-        <pc:spChg chg="mod">
-          <ac:chgData name="Tommaso Ghilardi (Staff)" userId="b9591c49-3913-47aa-a516-44e0ea4248a4" providerId="ADAL" clId="{0D36F859-059A-4DB7-AEC5-974ED1AC50D6}" dt="2025-08-30T11:40:56.345" v="613" actId="20577"/>
-          <ac:spMkLst>
-            <pc:docMk/>
-            <pc:sldMk cId="473977692" sldId="260"/>
-            <ac:spMk id="189" creationId="{8398F060-2CE1-B704-3068-1C13A3288CA6}"/>
-          </ac:spMkLst>
-        </pc:spChg>
-        <pc:spChg chg="mod">
-          <ac:chgData name="Tommaso Ghilardi (Staff)" userId="b9591c49-3913-47aa-a516-44e0ea4248a4" providerId="ADAL" clId="{0D36F859-059A-4DB7-AEC5-974ED1AC50D6}" dt="2025-08-30T21:25:11.010" v="641"/>
-          <ac:spMkLst>
-            <pc:docMk/>
-            <pc:sldMk cId="473977692" sldId="260"/>
-            <ac:spMk id="194" creationId="{9CDAC7FF-5D4B-AD6A-FA92-96548CE87DDC}"/>
-          </ac:spMkLst>
-        </pc:spChg>
-        <pc:spChg chg="mod">
-          <ac:chgData name="Tommaso Ghilardi (Staff)" userId="b9591c49-3913-47aa-a516-44e0ea4248a4" providerId="ADAL" clId="{0D36F859-059A-4DB7-AEC5-974ED1AC50D6}" dt="2025-08-30T11:40:28.033" v="571"/>
-          <ac:spMkLst>
-            <pc:docMk/>
-            <pc:sldMk cId="473977692" sldId="260"/>
-            <ac:spMk id="196" creationId="{D2E86D2C-E443-1086-B3BD-3141DCE6C993}"/>
-          </ac:spMkLst>
-        </pc:spChg>
-        <pc:spChg chg="mod">
-          <ac:chgData name="Tommaso Ghilardi (Staff)" userId="b9591c49-3913-47aa-a516-44e0ea4248a4" providerId="ADAL" clId="{0D36F859-059A-4DB7-AEC5-974ED1AC50D6}" dt="2025-08-30T11:41:07.712" v="614" actId="1076"/>
-          <ac:spMkLst>
-            <pc:docMk/>
-            <pc:sldMk cId="473977692" sldId="260"/>
-            <ac:spMk id="298" creationId="{820D5E88-0B57-3155-0368-5F6991E9D64D}"/>
-          </ac:spMkLst>
-        </pc:spChg>
-        <pc:spChg chg="mod">
-          <ac:chgData name="Tommaso Ghilardi (Staff)" userId="b9591c49-3913-47aa-a516-44e0ea4248a4" providerId="ADAL" clId="{0D36F859-059A-4DB7-AEC5-974ED1AC50D6}" dt="2025-08-30T21:28:43.315" v="646"/>
-          <ac:spMkLst>
-            <pc:docMk/>
-            <pc:sldMk cId="473977692" sldId="260"/>
-            <ac:spMk id="299" creationId="{35E7F8E2-CDA8-78E2-2F38-6C5FE5F9BAEE}"/>
-          </ac:spMkLst>
-        </pc:spChg>
-        <pc:spChg chg="mod">
-          <ac:chgData name="Tommaso Ghilardi (Staff)" userId="b9591c49-3913-47aa-a516-44e0ea4248a4" providerId="ADAL" clId="{0D36F859-059A-4DB7-AEC5-974ED1AC50D6}" dt="2025-08-30T11:37:38.704" v="522" actId="1036"/>
-          <ac:spMkLst>
-            <pc:docMk/>
-            <pc:sldMk cId="473977692" sldId="260"/>
-            <ac:spMk id="330" creationId="{FE02A376-9E3B-65BC-FFF4-4C999CE4DF2D}"/>
-          </ac:spMkLst>
-        </pc:spChg>
-        <pc:spChg chg="mod">
-          <ac:chgData name="Tommaso Ghilardi (Staff)" userId="b9591c49-3913-47aa-a516-44e0ea4248a4" providerId="ADAL" clId="{0D36F859-059A-4DB7-AEC5-974ED1AC50D6}" dt="2025-08-30T21:27:31.533" v="644"/>
-          <ac:spMkLst>
-            <pc:docMk/>
-            <pc:sldMk cId="473977692" sldId="260"/>
-            <ac:spMk id="346" creationId="{AB37A5FB-A5EE-70CE-4BF6-C37FEC5DCD52}"/>
-          </ac:spMkLst>
-        </pc:spChg>
-        <pc:spChg chg="mod">
-          <ac:chgData name="Tommaso Ghilardi (Staff)" userId="b9591c49-3913-47aa-a516-44e0ea4248a4" providerId="ADAL" clId="{0D36F859-059A-4DB7-AEC5-974ED1AC50D6}" dt="2025-08-30T11:37:38.704" v="522" actId="1036"/>
-          <ac:spMkLst>
-            <pc:docMk/>
-            <pc:sldMk cId="473977692" sldId="260"/>
-            <ac:spMk id="351" creationId="{0645E236-D46D-C0A1-4549-FD245688F3F4}"/>
-          </ac:spMkLst>
-        </pc:spChg>
-        <pc:spChg chg="mod">
-          <ac:chgData name="Tommaso Ghilardi (Staff)" userId="b9591c49-3913-47aa-a516-44e0ea4248a4" providerId="ADAL" clId="{0D36F859-059A-4DB7-AEC5-974ED1AC50D6}" dt="2025-08-30T11:37:38.704" v="522" actId="1036"/>
-          <ac:spMkLst>
-            <pc:docMk/>
-            <pc:sldMk cId="473977692" sldId="260"/>
-            <ac:spMk id="356" creationId="{2FE00998-FE6B-7D59-43F7-878FD843EBD9}"/>
-          </ac:spMkLst>
-        </pc:spChg>
-        <pc:spChg chg="mod">
-          <ac:chgData name="Tommaso Ghilardi (Staff)" userId="b9591c49-3913-47aa-a516-44e0ea4248a4" providerId="ADAL" clId="{0D36F859-059A-4DB7-AEC5-974ED1AC50D6}" dt="2025-08-30T21:31:02.859" v="683" actId="1036"/>
-          <ac:spMkLst>
-            <pc:docMk/>
-            <pc:sldMk cId="473977692" sldId="260"/>
-            <ac:spMk id="363" creationId="{2E5DDD62-31D5-DB35-7882-69ED9834C436}"/>
-          </ac:spMkLst>
-        </pc:spChg>
-        <pc:spChg chg="mod">
-          <ac:chgData name="Tommaso Ghilardi (Staff)" userId="b9591c49-3913-47aa-a516-44e0ea4248a4" providerId="ADAL" clId="{0D36F859-059A-4DB7-AEC5-974ED1AC50D6}" dt="2025-08-30T11:37:23.213" v="500" actId="1035"/>
-          <ac:spMkLst>
-            <pc:docMk/>
-            <pc:sldMk cId="473977692" sldId="260"/>
-            <ac:spMk id="417" creationId="{8B2E5F8C-A55D-207B-4971-B5FF6AD4E8F6}"/>
-          </ac:spMkLst>
-        </pc:spChg>
-        <pc:picChg chg="del">
-          <ac:chgData name="Tommaso Ghilardi (Staff)" userId="b9591c49-3913-47aa-a516-44e0ea4248a4" providerId="ADAL" clId="{0D36F859-059A-4DB7-AEC5-974ED1AC50D6}" dt="2025-08-30T11:41:57.955" v="616" actId="478"/>
-          <ac:picMkLst>
-            <pc:docMk/>
-            <pc:sldMk cId="473977692" sldId="260"/>
-            <ac:picMk id="2" creationId="{D20A8C1F-8B5B-5AD4-535A-87C3FA498950}"/>
-          </ac:picMkLst>
-        </pc:picChg>
-        <pc:picChg chg="add mod">
-          <ac:chgData name="Tommaso Ghilardi (Staff)" userId="b9591c49-3913-47aa-a516-44e0ea4248a4" providerId="ADAL" clId="{0D36F859-059A-4DB7-AEC5-974ED1AC50D6}" dt="2025-08-30T11:44:27.119" v="635" actId="1076"/>
-          <ac:picMkLst>
-            <pc:docMk/>
-            <pc:sldMk cId="473977692" sldId="260"/>
-            <ac:picMk id="29" creationId="{16483771-59DA-CADD-3F5A-585A15B7B5B1}"/>
-          </ac:picMkLst>
-        </pc:picChg>
-        <pc:picChg chg="add mod">
-          <ac:chgData name="Tommaso Ghilardi (Staff)" userId="b9591c49-3913-47aa-a516-44e0ea4248a4" providerId="ADAL" clId="{0D36F859-059A-4DB7-AEC5-974ED1AC50D6}" dt="2025-08-30T11:44:14.451" v="631" actId="14100"/>
-          <ac:picMkLst>
-            <pc:docMk/>
-            <pc:sldMk cId="473977692" sldId="260"/>
-            <ac:picMk id="33" creationId="{68BEA773-0D09-092E-4803-D1D999122227}"/>
-          </ac:picMkLst>
-        </pc:picChg>
-        <pc:picChg chg="mod">
-          <ac:chgData name="Tommaso Ghilardi (Staff)" userId="b9591c49-3913-47aa-a516-44e0ea4248a4" providerId="ADAL" clId="{0D36F859-059A-4DB7-AEC5-974ED1AC50D6}" dt="2025-08-30T11:41:21.575" v="615" actId="1076"/>
-          <ac:picMkLst>
-            <pc:docMk/>
-            <pc:sldMk cId="473977692" sldId="260"/>
-            <ac:picMk id="329" creationId="{3EED5478-C618-30DF-BBF4-CD9EA9F49989}"/>
-          </ac:picMkLst>
-        </pc:picChg>
-        <pc:picChg chg="mod">
-          <ac:chgData name="Tommaso Ghilardi (Staff)" userId="b9591c49-3913-47aa-a516-44e0ea4248a4" providerId="ADAL" clId="{0D36F859-059A-4DB7-AEC5-974ED1AC50D6}" dt="2025-08-30T11:37:38.704" v="522" actId="1036"/>
-          <ac:picMkLst>
-            <pc:docMk/>
-            <pc:sldMk cId="473977692" sldId="260"/>
-            <ac:picMk id="387" creationId="{A3C72F3B-BB9E-BC93-2E5E-4A4A46E0518A}"/>
-          </ac:picMkLst>
-        </pc:picChg>
-        <pc:cxnChg chg="mod">
-          <ac:chgData name="Tommaso Ghilardi (Staff)" userId="b9591c49-3913-47aa-a516-44e0ea4248a4" providerId="ADAL" clId="{0D36F859-059A-4DB7-AEC5-974ED1AC50D6}" dt="2025-08-30T11:39:10.143" v="559" actId="1035"/>
-          <ac:cxnSpMkLst>
-            <pc:docMk/>
-            <pc:sldMk cId="473977692" sldId="260"/>
-            <ac:cxnSpMk id="6" creationId="{319F6A1A-CC35-85AF-4E6D-1839BD1FC681}"/>
-          </ac:cxnSpMkLst>
-        </pc:cxnChg>
-        <pc:cxnChg chg="add mod">
-          <ac:chgData name="Tommaso Ghilardi (Staff)" userId="b9591c49-3913-47aa-a516-44e0ea4248a4" providerId="ADAL" clId="{0D36F859-059A-4DB7-AEC5-974ED1AC50D6}" dt="2025-08-30T21:31:15.016" v="686" actId="14100"/>
-          <ac:cxnSpMkLst>
-            <pc:docMk/>
-            <pc:sldMk cId="473977692" sldId="260"/>
-            <ac:cxnSpMk id="9" creationId="{E8D4028D-15BC-F7F7-2A57-9748317A9C0A}"/>
-          </ac:cxnSpMkLst>
-        </pc:cxnChg>
-        <pc:cxnChg chg="add mod">
-          <ac:chgData name="Tommaso Ghilardi (Staff)" userId="b9591c49-3913-47aa-a516-44e0ea4248a4" providerId="ADAL" clId="{0D36F859-059A-4DB7-AEC5-974ED1AC50D6}" dt="2025-08-30T11:40:07.465" v="569" actId="1036"/>
-          <ac:cxnSpMkLst>
-            <pc:docMk/>
-            <pc:sldMk cId="473977692" sldId="260"/>
-            <ac:cxnSpMk id="16" creationId="{72072F2C-2FF7-2AE7-40B2-0370ADFF4128}"/>
-          </ac:cxnSpMkLst>
-        </pc:cxnChg>
-        <pc:cxnChg chg="add mod">
-          <ac:chgData name="Tommaso Ghilardi (Staff)" userId="b9591c49-3913-47aa-a516-44e0ea4248a4" providerId="ADAL" clId="{0D36F859-059A-4DB7-AEC5-974ED1AC50D6}" dt="2025-08-30T11:40:07.465" v="569" actId="1036"/>
-          <ac:cxnSpMkLst>
-            <pc:docMk/>
-            <pc:sldMk cId="473977692" sldId="260"/>
-            <ac:cxnSpMk id="19" creationId="{89EF34DE-EECA-0B24-2CB5-4F39E3F051DC}"/>
-          </ac:cxnSpMkLst>
-        </pc:cxnChg>
-        <pc:cxnChg chg="add mod">
-          <ac:chgData name="Tommaso Ghilardi (Staff)" userId="b9591c49-3913-47aa-a516-44e0ea4248a4" providerId="ADAL" clId="{0D36F859-059A-4DB7-AEC5-974ED1AC50D6}" dt="2025-08-30T21:31:25.714" v="689" actId="14100"/>
-          <ac:cxnSpMkLst>
-            <pc:docMk/>
-            <pc:sldMk cId="473977692" sldId="260"/>
-            <ac:cxnSpMk id="20" creationId="{8B1A01E2-EFD1-3A83-A919-2ADD3090B9CB}"/>
-          </ac:cxnSpMkLst>
-        </pc:cxnChg>
-        <pc:cxnChg chg="mod">
-          <ac:chgData name="Tommaso Ghilardi (Staff)" userId="b9591c49-3913-47aa-a516-44e0ea4248a4" providerId="ADAL" clId="{0D36F859-059A-4DB7-AEC5-974ED1AC50D6}" dt="2025-08-30T21:31:02.859" v="683" actId="1036"/>
-          <ac:cxnSpMkLst>
-            <pc:docMk/>
-            <pc:sldMk cId="473977692" sldId="260"/>
-            <ac:cxnSpMk id="42" creationId="{24D4CCB7-8B43-9CA0-CCDA-15DFAE306AC8}"/>
-          </ac:cxnSpMkLst>
-        </pc:cxnChg>
-        <pc:cxnChg chg="mod">
-          <ac:chgData name="Tommaso Ghilardi (Staff)" userId="b9591c49-3913-47aa-a516-44e0ea4248a4" providerId="ADAL" clId="{0D36F859-059A-4DB7-AEC5-974ED1AC50D6}" dt="2025-08-30T21:31:02.859" v="683" actId="1036"/>
-          <ac:cxnSpMkLst>
-            <pc:docMk/>
-            <pc:sldMk cId="473977692" sldId="260"/>
-            <ac:cxnSpMk id="47" creationId="{52E80021-C2D3-F240-5DD5-2DB76113F856}"/>
-          </ac:cxnSpMkLst>
-        </pc:cxnChg>
-        <pc:cxnChg chg="mod">
-          <ac:chgData name="Tommaso Ghilardi (Staff)" userId="b9591c49-3913-47aa-a516-44e0ea4248a4" providerId="ADAL" clId="{0D36F859-059A-4DB7-AEC5-974ED1AC50D6}" dt="2025-08-30T21:31:02.859" v="683" actId="1036"/>
-          <ac:cxnSpMkLst>
-            <pc:docMk/>
-            <pc:sldMk cId="473977692" sldId="260"/>
-            <ac:cxnSpMk id="56" creationId="{DE56646E-8E93-8B19-8A58-247E98E83026}"/>
-          </ac:cxnSpMkLst>
-        </pc:cxnChg>
-        <pc:cxnChg chg="mod">
-          <ac:chgData name="Tommaso Ghilardi (Staff)" userId="b9591c49-3913-47aa-a516-44e0ea4248a4" providerId="ADAL" clId="{0D36F859-059A-4DB7-AEC5-974ED1AC50D6}" dt="2025-08-30T21:31:02.859" v="683" actId="1036"/>
-          <ac:cxnSpMkLst>
-            <pc:docMk/>
-            <pc:sldMk cId="473977692" sldId="260"/>
-            <ac:cxnSpMk id="77" creationId="{BE6629CB-E0BC-B37B-78A0-0D903A31F811}"/>
-          </ac:cxnSpMkLst>
-        </pc:cxnChg>
-        <pc:cxnChg chg="mod">
-          <ac:chgData name="Tommaso Ghilardi (Staff)" userId="b9591c49-3913-47aa-a516-44e0ea4248a4" providerId="ADAL" clId="{0D36F859-059A-4DB7-AEC5-974ED1AC50D6}" dt="2025-08-30T21:22:45.874" v="638" actId="1076"/>
-          <ac:cxnSpMkLst>
-            <pc:docMk/>
-            <pc:sldMk cId="473977692" sldId="260"/>
-            <ac:cxnSpMk id="175" creationId="{8884BBF1-D9B9-038A-65F2-B6BE227096CA}"/>
-          </ac:cxnSpMkLst>
-        </pc:cxnChg>
-        <pc:cxnChg chg="mod">
-          <ac:chgData name="Tommaso Ghilardi (Staff)" userId="b9591c49-3913-47aa-a516-44e0ea4248a4" providerId="ADAL" clId="{0D36F859-059A-4DB7-AEC5-974ED1AC50D6}" dt="2025-08-30T11:41:07.712" v="614" actId="1076"/>
-          <ac:cxnSpMkLst>
-            <pc:docMk/>
-            <pc:sldMk cId="473977692" sldId="260"/>
-            <ac:cxnSpMk id="304" creationId="{3CDCA431-F30A-1B1A-0B27-4F9FE4DE1456}"/>
-          </ac:cxnSpMkLst>
-        </pc:cxnChg>
-        <pc:cxnChg chg="mod">
-          <ac:chgData name="Tommaso Ghilardi (Staff)" userId="b9591c49-3913-47aa-a516-44e0ea4248a4" providerId="ADAL" clId="{0D36F859-059A-4DB7-AEC5-974ED1AC50D6}" dt="2025-08-30T11:41:07.712" v="614" actId="1076"/>
-          <ac:cxnSpMkLst>
-            <pc:docMk/>
-            <pc:sldMk cId="473977692" sldId="260"/>
-            <ac:cxnSpMk id="307" creationId="{4BC7B57E-B57F-CFE3-99A8-6EF23BDD705D}"/>
-          </ac:cxnSpMkLst>
-        </pc:cxnChg>
       </pc:sldChg>
       <pc:sldChg chg="addSp delSp modSp add del mod">
         <pc:chgData name="Tommaso Ghilardi (Staff)" userId="b9591c49-3913-47aa-a516-44e0ea4248a4" providerId="ADAL" clId="{0D36F859-059A-4DB7-AEC5-974ED1AC50D6}" dt="2025-08-29T17:10:34.638" v="394" actId="47"/>
@@ -493,494 +181,6 @@
           <pc:docMk/>
           <pc:sldMk cId="3385753680" sldId="260"/>
         </pc:sldMkLst>
-        <pc:spChg chg="mod">
-          <ac:chgData name="Tommaso Ghilardi (Staff)" userId="b9591c49-3913-47aa-a516-44e0ea4248a4" providerId="ADAL" clId="{0D36F859-059A-4DB7-AEC5-974ED1AC50D6}" dt="2025-08-29T16:50:50.241" v="1" actId="20577"/>
-          <ac:spMkLst>
-            <pc:docMk/>
-            <pc:sldMk cId="3385753680" sldId="260"/>
-            <ac:spMk id="2" creationId="{3748DC45-1C88-F4F3-6E74-437B32A04A5F}"/>
-          </ac:spMkLst>
-        </pc:spChg>
-        <pc:spChg chg="add del mod">
-          <ac:chgData name="Tommaso Ghilardi (Staff)" userId="b9591c49-3913-47aa-a516-44e0ea4248a4" providerId="ADAL" clId="{0D36F859-059A-4DB7-AEC5-974ED1AC50D6}" dt="2025-08-29T16:53:43.476" v="209" actId="478"/>
-          <ac:spMkLst>
-            <pc:docMk/>
-            <pc:sldMk cId="3385753680" sldId="260"/>
-            <ac:spMk id="3" creationId="{4238F431-CBC6-70D4-2A63-C19FD892FFF7}"/>
-          </ac:spMkLst>
-        </pc:spChg>
-        <pc:spChg chg="add del mod">
-          <ac:chgData name="Tommaso Ghilardi (Staff)" userId="b9591c49-3913-47aa-a516-44e0ea4248a4" providerId="ADAL" clId="{0D36F859-059A-4DB7-AEC5-974ED1AC50D6}" dt="2025-08-29T16:53:43.476" v="209" actId="478"/>
-          <ac:spMkLst>
-            <pc:docMk/>
-            <pc:sldMk cId="3385753680" sldId="260"/>
-            <ac:spMk id="5" creationId="{E78BA163-CC21-5A6C-5876-6558AE603B57}"/>
-          </ac:spMkLst>
-        </pc:spChg>
-        <pc:spChg chg="add mod">
-          <ac:chgData name="Tommaso Ghilardi (Staff)" userId="b9591c49-3913-47aa-a516-44e0ea4248a4" providerId="ADAL" clId="{0D36F859-059A-4DB7-AEC5-974ED1AC50D6}" dt="2025-08-29T17:02:51.446" v="383" actId="1076"/>
-          <ac:spMkLst>
-            <pc:docMk/>
-            <pc:sldMk cId="3385753680" sldId="260"/>
-            <ac:spMk id="15" creationId="{DFA300B6-B8C7-EDBD-7039-BF06054D7791}"/>
-          </ac:spMkLst>
-        </pc:spChg>
-        <pc:spChg chg="del mod">
-          <ac:chgData name="Tommaso Ghilardi (Staff)" userId="b9591c49-3913-47aa-a516-44e0ea4248a4" providerId="ADAL" clId="{0D36F859-059A-4DB7-AEC5-974ED1AC50D6}" dt="2025-08-29T16:57:08.809" v="264" actId="478"/>
-          <ac:spMkLst>
-            <pc:docMk/>
-            <pc:sldMk cId="3385753680" sldId="260"/>
-            <ac:spMk id="30" creationId="{0BFEE132-9003-E1BC-9F57-C3A49C16AC56}"/>
-          </ac:spMkLst>
-        </pc:spChg>
-        <pc:spChg chg="del mod">
-          <ac:chgData name="Tommaso Ghilardi (Staff)" userId="b9591c49-3913-47aa-a516-44e0ea4248a4" providerId="ADAL" clId="{0D36F859-059A-4DB7-AEC5-974ED1AC50D6}" dt="2025-08-29T16:51:19.208" v="15" actId="478"/>
-          <ac:spMkLst>
-            <pc:docMk/>
-            <pc:sldMk cId="3385753680" sldId="260"/>
-            <ac:spMk id="46" creationId="{5D577444-4004-045D-7A05-42398BC3B111}"/>
-          </ac:spMkLst>
-        </pc:spChg>
-        <pc:spChg chg="del">
-          <ac:chgData name="Tommaso Ghilardi (Staff)" userId="b9591c49-3913-47aa-a516-44e0ea4248a4" providerId="ADAL" clId="{0D36F859-059A-4DB7-AEC5-974ED1AC50D6}" dt="2025-08-29T16:51:19.208" v="15" actId="478"/>
-          <ac:spMkLst>
-            <pc:docMk/>
-            <pc:sldMk cId="3385753680" sldId="260"/>
-            <ac:spMk id="48" creationId="{941FA761-963D-7074-0F49-89CD7A0ADC8A}"/>
-          </ac:spMkLst>
-        </pc:spChg>
-        <pc:spChg chg="del">
-          <ac:chgData name="Tommaso Ghilardi (Staff)" userId="b9591c49-3913-47aa-a516-44e0ea4248a4" providerId="ADAL" clId="{0D36F859-059A-4DB7-AEC5-974ED1AC50D6}" dt="2025-08-29T16:51:10.594" v="14" actId="478"/>
-          <ac:spMkLst>
-            <pc:docMk/>
-            <pc:sldMk cId="3385753680" sldId="260"/>
-            <ac:spMk id="55" creationId="{397E92F6-12CB-919D-9579-40A8F87F3152}"/>
-          </ac:spMkLst>
-        </pc:spChg>
-        <pc:spChg chg="del">
-          <ac:chgData name="Tommaso Ghilardi (Staff)" userId="b9591c49-3913-47aa-a516-44e0ea4248a4" providerId="ADAL" clId="{0D36F859-059A-4DB7-AEC5-974ED1AC50D6}" dt="2025-08-29T16:51:19.208" v="15" actId="478"/>
-          <ac:spMkLst>
-            <pc:docMk/>
-            <pc:sldMk cId="3385753680" sldId="260"/>
-            <ac:spMk id="57" creationId="{48CB3AF2-EDA0-C60B-231C-02F2FE1E50D3}"/>
-          </ac:spMkLst>
-        </pc:spChg>
-        <pc:spChg chg="del">
-          <ac:chgData name="Tommaso Ghilardi (Staff)" userId="b9591c49-3913-47aa-a516-44e0ea4248a4" providerId="ADAL" clId="{0D36F859-059A-4DB7-AEC5-974ED1AC50D6}" dt="2025-08-29T16:51:09.157" v="13" actId="478"/>
-          <ac:spMkLst>
-            <pc:docMk/>
-            <pc:sldMk cId="3385753680" sldId="260"/>
-            <ac:spMk id="58" creationId="{4CE6EDC1-2D79-C335-0605-9FDB68DA9803}"/>
-          </ac:spMkLst>
-        </pc:spChg>
-        <pc:spChg chg="mod">
-          <ac:chgData name="Tommaso Ghilardi (Staff)" userId="b9591c49-3913-47aa-a516-44e0ea4248a4" providerId="ADAL" clId="{0D36F859-059A-4DB7-AEC5-974ED1AC50D6}" dt="2025-08-29T17:02:01.529" v="362" actId="20577"/>
-          <ac:spMkLst>
-            <pc:docMk/>
-            <pc:sldMk cId="3385753680" sldId="260"/>
-            <ac:spMk id="59" creationId="{F07EBDBA-B9A2-C1C0-86D1-AF3EBFCB1786}"/>
-          </ac:spMkLst>
-        </pc:spChg>
-        <pc:spChg chg="del">
-          <ac:chgData name="Tommaso Ghilardi (Staff)" userId="b9591c49-3913-47aa-a516-44e0ea4248a4" providerId="ADAL" clId="{0D36F859-059A-4DB7-AEC5-974ED1AC50D6}" dt="2025-08-29T16:51:19.208" v="15" actId="478"/>
-          <ac:spMkLst>
-            <pc:docMk/>
-            <pc:sldMk cId="3385753680" sldId="260"/>
-            <ac:spMk id="65" creationId="{70F39C8F-F3FF-145F-76A6-F81ED7E104C9}"/>
-          </ac:spMkLst>
-        </pc:spChg>
-        <pc:spChg chg="mod">
-          <ac:chgData name="Tommaso Ghilardi (Staff)" userId="b9591c49-3913-47aa-a516-44e0ea4248a4" providerId="ADAL" clId="{0D36F859-059A-4DB7-AEC5-974ED1AC50D6}" dt="2025-08-29T16:53:56.069" v="212" actId="14100"/>
-          <ac:spMkLst>
-            <pc:docMk/>
-            <pc:sldMk cId="3385753680" sldId="260"/>
-            <ac:spMk id="103" creationId="{B1A42515-5043-D454-C58F-AD7C1FC354C3}"/>
-          </ac:spMkLst>
-        </pc:spChg>
-        <pc:spChg chg="mod">
-          <ac:chgData name="Tommaso Ghilardi (Staff)" userId="b9591c49-3913-47aa-a516-44e0ea4248a4" providerId="ADAL" clId="{0D36F859-059A-4DB7-AEC5-974ED1AC50D6}" dt="2025-08-29T16:51:53.725" v="52" actId="20577"/>
-          <ac:spMkLst>
-            <pc:docMk/>
-            <pc:sldMk cId="3385753680" sldId="260"/>
-            <ac:spMk id="160" creationId="{A61DCCA1-F9C2-5B0C-BE08-514DB17B7324}"/>
-          </ac:spMkLst>
-        </pc:spChg>
-        <pc:spChg chg="mod">
-          <ac:chgData name="Tommaso Ghilardi (Staff)" userId="b9591c49-3913-47aa-a516-44e0ea4248a4" providerId="ADAL" clId="{0D36F859-059A-4DB7-AEC5-974ED1AC50D6}" dt="2025-08-29T16:51:33.708" v="20" actId="1076"/>
-          <ac:spMkLst>
-            <pc:docMk/>
-            <pc:sldMk cId="3385753680" sldId="260"/>
-            <ac:spMk id="165" creationId="{E18E0C6C-DF41-F5BB-E99B-07D7F78A9468}"/>
-          </ac:spMkLst>
-        </pc:spChg>
-        <pc:spChg chg="mod">
-          <ac:chgData name="Tommaso Ghilardi (Staff)" userId="b9591c49-3913-47aa-a516-44e0ea4248a4" providerId="ADAL" clId="{0D36F859-059A-4DB7-AEC5-974ED1AC50D6}" dt="2025-08-29T16:51:33.708" v="20" actId="1076"/>
-          <ac:spMkLst>
-            <pc:docMk/>
-            <pc:sldMk cId="3385753680" sldId="260"/>
-            <ac:spMk id="167" creationId="{2C358D5C-84DC-E6F3-6072-A454B4A6F02C}"/>
-          </ac:spMkLst>
-        </pc:spChg>
-        <pc:spChg chg="mod">
-          <ac:chgData name="Tommaso Ghilardi (Staff)" userId="b9591c49-3913-47aa-a516-44e0ea4248a4" providerId="ADAL" clId="{0D36F859-059A-4DB7-AEC5-974ED1AC50D6}" dt="2025-08-29T16:52:16.847" v="110" actId="20577"/>
-          <ac:spMkLst>
-            <pc:docMk/>
-            <pc:sldMk cId="3385753680" sldId="260"/>
-            <ac:spMk id="189" creationId="{1BB1A36C-D3DE-6779-160C-EB507B0E1C29}"/>
-          </ac:spMkLst>
-        </pc:spChg>
-        <pc:spChg chg="mod">
-          <ac:chgData name="Tommaso Ghilardi (Staff)" userId="b9591c49-3913-47aa-a516-44e0ea4248a4" providerId="ADAL" clId="{0D36F859-059A-4DB7-AEC5-974ED1AC50D6}" dt="2025-08-29T16:51:33.708" v="20" actId="1076"/>
-          <ac:spMkLst>
-            <pc:docMk/>
-            <pc:sldMk cId="3385753680" sldId="260"/>
-            <ac:spMk id="194" creationId="{1C5F7E85-B3CC-DDA0-268F-F46D484256DC}"/>
-          </ac:spMkLst>
-        </pc:spChg>
-        <pc:spChg chg="mod">
-          <ac:chgData name="Tommaso Ghilardi (Staff)" userId="b9591c49-3913-47aa-a516-44e0ea4248a4" providerId="ADAL" clId="{0D36F859-059A-4DB7-AEC5-974ED1AC50D6}" dt="2025-08-29T16:53:14.290" v="205" actId="313"/>
-          <ac:spMkLst>
-            <pc:docMk/>
-            <pc:sldMk cId="3385753680" sldId="260"/>
-            <ac:spMk id="196" creationId="{131AD033-4BF6-2CB9-2B20-6BCC9C88031E}"/>
-          </ac:spMkLst>
-        </pc:spChg>
-        <pc:spChg chg="mod">
-          <ac:chgData name="Tommaso Ghilardi (Staff)" userId="b9591c49-3913-47aa-a516-44e0ea4248a4" providerId="ADAL" clId="{0D36F859-059A-4DB7-AEC5-974ED1AC50D6}" dt="2025-08-29T16:51:33.708" v="20" actId="1076"/>
-          <ac:spMkLst>
-            <pc:docMk/>
-            <pc:sldMk cId="3385753680" sldId="260"/>
-            <ac:spMk id="239" creationId="{C7B4A8E9-48E6-E56C-94AA-335BCD028649}"/>
-          </ac:spMkLst>
-        </pc:spChg>
-        <pc:spChg chg="del mod">
-          <ac:chgData name="Tommaso Ghilardi (Staff)" userId="b9591c49-3913-47aa-a516-44e0ea4248a4" providerId="ADAL" clId="{0D36F859-059A-4DB7-AEC5-974ED1AC50D6}" dt="2025-08-29T16:56:54.377" v="259" actId="478"/>
-          <ac:spMkLst>
-            <pc:docMk/>
-            <pc:sldMk cId="3385753680" sldId="260"/>
-            <ac:spMk id="298" creationId="{71A6DE5D-0C93-458C-DF08-D777E40E24BF}"/>
-          </ac:spMkLst>
-        </pc:spChg>
-        <pc:spChg chg="del mod">
-          <ac:chgData name="Tommaso Ghilardi (Staff)" userId="b9591c49-3913-47aa-a516-44e0ea4248a4" providerId="ADAL" clId="{0D36F859-059A-4DB7-AEC5-974ED1AC50D6}" dt="2025-08-29T16:56:53.114" v="258" actId="478"/>
-          <ac:spMkLst>
-            <pc:docMk/>
-            <pc:sldMk cId="3385753680" sldId="260"/>
-            <ac:spMk id="299" creationId="{3B6E111B-87B6-88F9-18C1-13F24302E594}"/>
-          </ac:spMkLst>
-        </pc:spChg>
-        <pc:spChg chg="mod">
-          <ac:chgData name="Tommaso Ghilardi (Staff)" userId="b9591c49-3913-47aa-a516-44e0ea4248a4" providerId="ADAL" clId="{0D36F859-059A-4DB7-AEC5-974ED1AC50D6}" dt="2025-08-29T17:02:23.980" v="379" actId="6549"/>
-          <ac:spMkLst>
-            <pc:docMk/>
-            <pc:sldMk cId="3385753680" sldId="260"/>
-            <ac:spMk id="330" creationId="{06E73439-4535-5659-0077-DCB1656E74B8}"/>
-          </ac:spMkLst>
-        </pc:spChg>
-        <pc:spChg chg="mod">
-          <ac:chgData name="Tommaso Ghilardi (Staff)" userId="b9591c49-3913-47aa-a516-44e0ea4248a4" providerId="ADAL" clId="{0D36F859-059A-4DB7-AEC5-974ED1AC50D6}" dt="2025-08-29T17:00:49.626" v="310" actId="1076"/>
-          <ac:spMkLst>
-            <pc:docMk/>
-            <pc:sldMk cId="3385753680" sldId="260"/>
-            <ac:spMk id="346" creationId="{6809C222-3E55-5E9F-E93B-09A77EF2B877}"/>
-          </ac:spMkLst>
-        </pc:spChg>
-        <pc:spChg chg="mod">
-          <ac:chgData name="Tommaso Ghilardi (Staff)" userId="b9591c49-3913-47aa-a516-44e0ea4248a4" providerId="ADAL" clId="{0D36F859-059A-4DB7-AEC5-974ED1AC50D6}" dt="2025-08-29T17:01:40.297" v="353" actId="20577"/>
-          <ac:spMkLst>
-            <pc:docMk/>
-            <pc:sldMk cId="3385753680" sldId="260"/>
-            <ac:spMk id="351" creationId="{6EA7600C-6C54-3105-A18C-9017A16B3D21}"/>
-          </ac:spMkLst>
-        </pc:spChg>
-        <pc:spChg chg="del mod">
-          <ac:chgData name="Tommaso Ghilardi (Staff)" userId="b9591c49-3913-47aa-a516-44e0ea4248a4" providerId="ADAL" clId="{0D36F859-059A-4DB7-AEC5-974ED1AC50D6}" dt="2025-08-29T17:03:21.076" v="389" actId="478"/>
-          <ac:spMkLst>
-            <pc:docMk/>
-            <pc:sldMk cId="3385753680" sldId="260"/>
-            <ac:spMk id="356" creationId="{F81E4071-9C3F-3936-7A55-54F00982D6CD}"/>
-          </ac:spMkLst>
-        </pc:spChg>
-        <pc:spChg chg="mod">
-          <ac:chgData name="Tommaso Ghilardi (Staff)" userId="b9591c49-3913-47aa-a516-44e0ea4248a4" providerId="ADAL" clId="{0D36F859-059A-4DB7-AEC5-974ED1AC50D6}" dt="2025-08-29T17:03:00.198" v="384" actId="1076"/>
-          <ac:spMkLst>
-            <pc:docMk/>
-            <pc:sldMk cId="3385753680" sldId="260"/>
-            <ac:spMk id="363" creationId="{9319AFEF-4A5B-08F3-5D86-49BC1B2B3E0B}"/>
-          </ac:spMkLst>
-        </pc:spChg>
-        <pc:spChg chg="mod">
-          <ac:chgData name="Tommaso Ghilardi (Staff)" userId="b9591c49-3913-47aa-a516-44e0ea4248a4" providerId="ADAL" clId="{0D36F859-059A-4DB7-AEC5-974ED1AC50D6}" dt="2025-08-29T17:01:49.962" v="357" actId="1076"/>
-          <ac:spMkLst>
-            <pc:docMk/>
-            <pc:sldMk cId="3385753680" sldId="260"/>
-            <ac:spMk id="417" creationId="{C673FA4E-BE89-1311-DCFA-DAD53A6CE2E9}"/>
-          </ac:spMkLst>
-        </pc:spChg>
-        <pc:picChg chg="del">
-          <ac:chgData name="Tommaso Ghilardi (Staff)" userId="b9591c49-3913-47aa-a516-44e0ea4248a4" providerId="ADAL" clId="{0D36F859-059A-4DB7-AEC5-974ED1AC50D6}" dt="2025-08-29T16:51:19.208" v="15" actId="478"/>
-          <ac:picMkLst>
-            <pc:docMk/>
-            <pc:sldMk cId="3385753680" sldId="260"/>
-            <ac:picMk id="49" creationId="{53741F94-459C-38A9-5B3D-5299EC9BB9EB}"/>
-          </ac:picMkLst>
-        </pc:picChg>
-        <pc:picChg chg="del">
-          <ac:chgData name="Tommaso Ghilardi (Staff)" userId="b9591c49-3913-47aa-a516-44e0ea4248a4" providerId="ADAL" clId="{0D36F859-059A-4DB7-AEC5-974ED1AC50D6}" dt="2025-08-29T16:51:19.208" v="15" actId="478"/>
-          <ac:picMkLst>
-            <pc:docMk/>
-            <pc:sldMk cId="3385753680" sldId="260"/>
-            <ac:picMk id="218" creationId="{B4466213-2FCF-ECC5-A4AD-61265714B9E4}"/>
-          </ac:picMkLst>
-        </pc:picChg>
-        <pc:picChg chg="del">
-          <ac:chgData name="Tommaso Ghilardi (Staff)" userId="b9591c49-3913-47aa-a516-44e0ea4248a4" providerId="ADAL" clId="{0D36F859-059A-4DB7-AEC5-974ED1AC50D6}" dt="2025-08-29T16:51:19.208" v="15" actId="478"/>
-          <ac:picMkLst>
-            <pc:docMk/>
-            <pc:sldMk cId="3385753680" sldId="260"/>
-            <ac:picMk id="219" creationId="{0B75812E-6228-9FB2-0677-A1BC2146E6D8}"/>
-          </ac:picMkLst>
-        </pc:picChg>
-        <pc:picChg chg="del">
-          <ac:chgData name="Tommaso Ghilardi (Staff)" userId="b9591c49-3913-47aa-a516-44e0ea4248a4" providerId="ADAL" clId="{0D36F859-059A-4DB7-AEC5-974ED1AC50D6}" dt="2025-08-29T16:51:19.208" v="15" actId="478"/>
-          <ac:picMkLst>
-            <pc:docMk/>
-            <pc:sldMk cId="3385753680" sldId="260"/>
-            <ac:picMk id="231" creationId="{9B7D55D5-2163-A269-CAA1-F4FCA36B15B3}"/>
-          </ac:picMkLst>
-        </pc:picChg>
-        <pc:picChg chg="del">
-          <ac:chgData name="Tommaso Ghilardi (Staff)" userId="b9591c49-3913-47aa-a516-44e0ea4248a4" providerId="ADAL" clId="{0D36F859-059A-4DB7-AEC5-974ED1AC50D6}" dt="2025-08-29T16:51:19.208" v="15" actId="478"/>
-          <ac:picMkLst>
-            <pc:docMk/>
-            <pc:sldMk cId="3385753680" sldId="260"/>
-            <ac:picMk id="232" creationId="{1E1E8390-A6D5-1777-C487-FCD387CEAE1C}"/>
-          </ac:picMkLst>
-        </pc:picChg>
-        <pc:picChg chg="del mod">
-          <ac:chgData name="Tommaso Ghilardi (Staff)" userId="b9591c49-3913-47aa-a516-44e0ea4248a4" providerId="ADAL" clId="{0D36F859-059A-4DB7-AEC5-974ED1AC50D6}" dt="2025-08-29T17:03:21.076" v="389" actId="478"/>
-          <ac:picMkLst>
-            <pc:docMk/>
-            <pc:sldMk cId="3385753680" sldId="260"/>
-            <ac:picMk id="328" creationId="{EEAE8B6C-EA69-122F-76F4-A86929B74159}"/>
-          </ac:picMkLst>
-        </pc:picChg>
-        <pc:picChg chg="del mod">
-          <ac:chgData name="Tommaso Ghilardi (Staff)" userId="b9591c49-3913-47aa-a516-44e0ea4248a4" providerId="ADAL" clId="{0D36F859-059A-4DB7-AEC5-974ED1AC50D6}" dt="2025-08-29T17:03:21.076" v="389" actId="478"/>
-          <ac:picMkLst>
-            <pc:docMk/>
-            <pc:sldMk cId="3385753680" sldId="260"/>
-            <ac:picMk id="329" creationId="{684E2AF0-08DB-7292-318E-AAED010CED5C}"/>
-          </ac:picMkLst>
-        </pc:picChg>
-        <pc:picChg chg="del mod">
-          <ac:chgData name="Tommaso Ghilardi (Staff)" userId="b9591c49-3913-47aa-a516-44e0ea4248a4" providerId="ADAL" clId="{0D36F859-059A-4DB7-AEC5-974ED1AC50D6}" dt="2025-08-29T17:03:21.076" v="389" actId="478"/>
-          <ac:picMkLst>
-            <pc:docMk/>
-            <pc:sldMk cId="3385753680" sldId="260"/>
-            <ac:picMk id="386" creationId="{A66B6261-4C85-1A9A-B853-025B22A29C5C}"/>
-          </ac:picMkLst>
-        </pc:picChg>
-        <pc:picChg chg="del mod">
-          <ac:chgData name="Tommaso Ghilardi (Staff)" userId="b9591c49-3913-47aa-a516-44e0ea4248a4" providerId="ADAL" clId="{0D36F859-059A-4DB7-AEC5-974ED1AC50D6}" dt="2025-08-29T17:03:21.076" v="389" actId="478"/>
-          <ac:picMkLst>
-            <pc:docMk/>
-            <pc:sldMk cId="3385753680" sldId="260"/>
-            <ac:picMk id="387" creationId="{004917E4-DCC6-F5B4-0940-240A6157C6B4}"/>
-          </ac:picMkLst>
-        </pc:picChg>
-        <pc:picChg chg="del">
-          <ac:chgData name="Tommaso Ghilardi (Staff)" userId="b9591c49-3913-47aa-a516-44e0ea4248a4" providerId="ADAL" clId="{0D36F859-059A-4DB7-AEC5-974ED1AC50D6}" dt="2025-08-29T16:51:19.208" v="15" actId="478"/>
-          <ac:picMkLst>
-            <pc:docMk/>
-            <pc:sldMk cId="3385753680" sldId="260"/>
-            <ac:picMk id="407" creationId="{CB5C006F-95EA-F4DA-4FE5-7FC533EBF55F}"/>
-          </ac:picMkLst>
-        </pc:picChg>
-        <pc:picChg chg="mod">
-          <ac:chgData name="Tommaso Ghilardi (Staff)" userId="b9591c49-3913-47aa-a516-44e0ea4248a4" providerId="ADAL" clId="{0D36F859-059A-4DB7-AEC5-974ED1AC50D6}" dt="2025-08-29T17:01:49.962" v="357" actId="1076"/>
-          <ac:picMkLst>
-            <pc:docMk/>
-            <pc:sldMk cId="3385753680" sldId="260"/>
-            <ac:picMk id="416" creationId="{8D83BF76-9546-066C-77A5-32747A545941}"/>
-          </ac:picMkLst>
-        </pc:picChg>
-        <pc:cxnChg chg="add del mod">
-          <ac:chgData name="Tommaso Ghilardi (Staff)" userId="b9591c49-3913-47aa-a516-44e0ea4248a4" providerId="ADAL" clId="{0D36F859-059A-4DB7-AEC5-974ED1AC50D6}" dt="2025-08-29T16:53:43.476" v="209" actId="478"/>
-          <ac:cxnSpMkLst>
-            <pc:docMk/>
-            <pc:sldMk cId="3385753680" sldId="260"/>
-            <ac:cxnSpMk id="4" creationId="{077E0776-C5F5-7692-410C-01E8CFEB20AD}"/>
-          </ac:cxnSpMkLst>
-        </pc:cxnChg>
-        <pc:cxnChg chg="add del mod">
-          <ac:chgData name="Tommaso Ghilardi (Staff)" userId="b9591c49-3913-47aa-a516-44e0ea4248a4" providerId="ADAL" clId="{0D36F859-059A-4DB7-AEC5-974ED1AC50D6}" dt="2025-08-29T17:03:13.744" v="388" actId="14100"/>
-          <ac:cxnSpMkLst>
-            <pc:docMk/>
-            <pc:sldMk cId="3385753680" sldId="260"/>
-            <ac:cxnSpMk id="6" creationId="{D33B770E-6D91-B9DE-FF27-B21102EDE9B6}"/>
-          </ac:cxnSpMkLst>
-        </pc:cxnChg>
-        <pc:cxnChg chg="del mod">
-          <ac:chgData name="Tommaso Ghilardi (Staff)" userId="b9591c49-3913-47aa-a516-44e0ea4248a4" providerId="ADAL" clId="{0D36F859-059A-4DB7-AEC5-974ED1AC50D6}" dt="2025-08-29T16:53:46.003" v="210" actId="478"/>
-          <ac:cxnSpMkLst>
-            <pc:docMk/>
-            <pc:sldMk cId="3385753680" sldId="260"/>
-            <ac:cxnSpMk id="7" creationId="{7FC1F429-7D42-ED33-F925-75B747EE298B}"/>
-          </ac:cxnSpMkLst>
-        </pc:cxnChg>
-        <pc:cxnChg chg="mod">
-          <ac:chgData name="Tommaso Ghilardi (Staff)" userId="b9591c49-3913-47aa-a516-44e0ea4248a4" providerId="ADAL" clId="{0D36F859-059A-4DB7-AEC5-974ED1AC50D6}" dt="2025-08-29T17:01:08.278" v="316" actId="14100"/>
-          <ac:cxnSpMkLst>
-            <pc:docMk/>
-            <pc:sldMk cId="3385753680" sldId="260"/>
-            <ac:cxnSpMk id="42" creationId="{C00EAA6A-967F-B7BB-A566-B570DBCA4121}"/>
-          </ac:cxnSpMkLst>
-        </pc:cxnChg>
-        <pc:cxnChg chg="add mod">
-          <ac:chgData name="Tommaso Ghilardi (Staff)" userId="b9591c49-3913-47aa-a516-44e0ea4248a4" providerId="ADAL" clId="{0D36F859-059A-4DB7-AEC5-974ED1AC50D6}" dt="2025-08-29T17:03:00.198" v="384" actId="1076"/>
-          <ac:cxnSpMkLst>
-            <pc:docMk/>
-            <pc:sldMk cId="3385753680" sldId="260"/>
-            <ac:cxnSpMk id="44" creationId="{2836FF54-7FB5-3244-0498-FA1DACEB38DF}"/>
-          </ac:cxnSpMkLst>
-        </pc:cxnChg>
-        <pc:cxnChg chg="mod">
-          <ac:chgData name="Tommaso Ghilardi (Staff)" userId="b9591c49-3913-47aa-a516-44e0ea4248a4" providerId="ADAL" clId="{0D36F859-059A-4DB7-AEC5-974ED1AC50D6}" dt="2025-08-29T17:02:51.446" v="383" actId="1076"/>
-          <ac:cxnSpMkLst>
-            <pc:docMk/>
-            <pc:sldMk cId="3385753680" sldId="260"/>
-            <ac:cxnSpMk id="47" creationId="{4A3CC929-CA90-82AB-8D75-D1AB63940ECD}"/>
-          </ac:cxnSpMkLst>
-        </pc:cxnChg>
-        <pc:cxnChg chg="del mod">
-          <ac:chgData name="Tommaso Ghilardi (Staff)" userId="b9591c49-3913-47aa-a516-44e0ea4248a4" providerId="ADAL" clId="{0D36F859-059A-4DB7-AEC5-974ED1AC50D6}" dt="2025-08-29T16:56:00.459" v="248" actId="478"/>
-          <ac:cxnSpMkLst>
-            <pc:docMk/>
-            <pc:sldMk cId="3385753680" sldId="260"/>
-            <ac:cxnSpMk id="56" creationId="{4E409A1F-0B0C-A5A5-EC82-02617E2F3C8F}"/>
-          </ac:cxnSpMkLst>
-        </pc:cxnChg>
-        <pc:cxnChg chg="del mod">
-          <ac:chgData name="Tommaso Ghilardi (Staff)" userId="b9591c49-3913-47aa-a516-44e0ea4248a4" providerId="ADAL" clId="{0D36F859-059A-4DB7-AEC5-974ED1AC50D6}" dt="2025-08-29T16:55:58.844" v="247" actId="478"/>
-          <ac:cxnSpMkLst>
-            <pc:docMk/>
-            <pc:sldMk cId="3385753680" sldId="260"/>
-            <ac:cxnSpMk id="77" creationId="{7A98067A-59E9-9BC9-87FD-E3C716C9B0E0}"/>
-          </ac:cxnSpMkLst>
-        </pc:cxnChg>
-        <pc:cxnChg chg="mod">
-          <ac:chgData name="Tommaso Ghilardi (Staff)" userId="b9591c49-3913-47aa-a516-44e0ea4248a4" providerId="ADAL" clId="{0D36F859-059A-4DB7-AEC5-974ED1AC50D6}" dt="2025-08-29T16:51:10.594" v="14" actId="478"/>
-          <ac:cxnSpMkLst>
-            <pc:docMk/>
-            <pc:sldMk cId="3385753680" sldId="260"/>
-            <ac:cxnSpMk id="81" creationId="{496AE5A8-14D6-76BC-E6C9-7EA3D5C74615}"/>
-          </ac:cxnSpMkLst>
-        </pc:cxnChg>
-        <pc:cxnChg chg="add mod">
-          <ac:chgData name="Tommaso Ghilardi (Staff)" userId="b9591c49-3913-47aa-a516-44e0ea4248a4" providerId="ADAL" clId="{0D36F859-059A-4DB7-AEC5-974ED1AC50D6}" dt="2025-08-29T17:03:10.345" v="387" actId="14100"/>
-          <ac:cxnSpMkLst>
-            <pc:docMk/>
-            <pc:sldMk cId="3385753680" sldId="260"/>
-            <ac:cxnSpMk id="111" creationId="{8B1D3DBF-AFA1-3F17-A964-7072F2A83972}"/>
-          </ac:cxnSpMkLst>
-        </pc:cxnChg>
-        <pc:cxnChg chg="del">
-          <ac:chgData name="Tommaso Ghilardi (Staff)" userId="b9591c49-3913-47aa-a516-44e0ea4248a4" providerId="ADAL" clId="{0D36F859-059A-4DB7-AEC5-974ED1AC50D6}" dt="2025-08-29T16:51:20.729" v="16" actId="478"/>
-          <ac:cxnSpMkLst>
-            <pc:docMk/>
-            <pc:sldMk cId="3385753680" sldId="260"/>
-            <ac:cxnSpMk id="139" creationId="{30F5EF37-760A-B73C-06F4-3A16004D2AA9}"/>
-          </ac:cxnSpMkLst>
-        </pc:cxnChg>
-        <pc:cxnChg chg="del mod">
-          <ac:chgData name="Tommaso Ghilardi (Staff)" userId="b9591c49-3913-47aa-a516-44e0ea4248a4" providerId="ADAL" clId="{0D36F859-059A-4DB7-AEC5-974ED1AC50D6}" dt="2025-08-29T16:51:21.814" v="17" actId="478"/>
-          <ac:cxnSpMkLst>
-            <pc:docMk/>
-            <pc:sldMk cId="3385753680" sldId="260"/>
-            <ac:cxnSpMk id="246" creationId="{CDA48363-35EE-FE14-D1FE-FB2C448F110D}"/>
-          </ac:cxnSpMkLst>
-        </pc:cxnChg>
-        <pc:cxnChg chg="mod">
-          <ac:chgData name="Tommaso Ghilardi (Staff)" userId="b9591c49-3913-47aa-a516-44e0ea4248a4" providerId="ADAL" clId="{0D36F859-059A-4DB7-AEC5-974ED1AC50D6}" dt="2025-08-29T16:51:10.594" v="14" actId="478"/>
-          <ac:cxnSpMkLst>
-            <pc:docMk/>
-            <pc:sldMk cId="3385753680" sldId="260"/>
-            <ac:cxnSpMk id="255" creationId="{DC3F058D-23BA-7EAB-8CFE-4975D63ADCA9}"/>
-          </ac:cxnSpMkLst>
-        </pc:cxnChg>
-        <pc:cxnChg chg="mod">
-          <ac:chgData name="Tommaso Ghilardi (Staff)" userId="b9591c49-3913-47aa-a516-44e0ea4248a4" providerId="ADAL" clId="{0D36F859-059A-4DB7-AEC5-974ED1AC50D6}" dt="2025-08-29T16:51:10.594" v="14" actId="478"/>
-          <ac:cxnSpMkLst>
-            <pc:docMk/>
-            <pc:sldMk cId="3385753680" sldId="260"/>
-            <ac:cxnSpMk id="260" creationId="{8E4F25D4-F311-CF38-7A55-7AA629F037C8}"/>
-          </ac:cxnSpMkLst>
-        </pc:cxnChg>
-        <pc:cxnChg chg="mod">
-          <ac:chgData name="Tommaso Ghilardi (Staff)" userId="b9591c49-3913-47aa-a516-44e0ea4248a4" providerId="ADAL" clId="{0D36F859-059A-4DB7-AEC5-974ED1AC50D6}" dt="2025-08-29T17:02:51.446" v="383" actId="1076"/>
-          <ac:cxnSpMkLst>
-            <pc:docMk/>
-            <pc:sldMk cId="3385753680" sldId="260"/>
-            <ac:cxnSpMk id="304" creationId="{822D1E2E-9485-3C91-2BB2-2AC81CEFBC67}"/>
-          </ac:cxnSpMkLst>
-        </pc:cxnChg>
-        <pc:cxnChg chg="del mod">
-          <ac:chgData name="Tommaso Ghilardi (Staff)" userId="b9591c49-3913-47aa-a516-44e0ea4248a4" providerId="ADAL" clId="{0D36F859-059A-4DB7-AEC5-974ED1AC50D6}" dt="2025-08-29T16:56:56.151" v="260" actId="478"/>
-          <ac:cxnSpMkLst>
-            <pc:docMk/>
-            <pc:sldMk cId="3385753680" sldId="260"/>
-            <ac:cxnSpMk id="307" creationId="{4EFC1BBF-75F3-F3AD-BF42-45C3017DB253}"/>
-          </ac:cxnSpMkLst>
-        </pc:cxnChg>
-        <pc:cxnChg chg="mod">
-          <ac:chgData name="Tommaso Ghilardi (Staff)" userId="b9591c49-3913-47aa-a516-44e0ea4248a4" providerId="ADAL" clId="{0D36F859-059A-4DB7-AEC5-974ED1AC50D6}" dt="2025-08-29T16:55:17.293" v="238" actId="1076"/>
-          <ac:cxnSpMkLst>
-            <pc:docMk/>
-            <pc:sldMk cId="3385753680" sldId="260"/>
-            <ac:cxnSpMk id="343" creationId="{B8C07C79-7EFF-6FE1-6526-5CC9627CA14E}"/>
-          </ac:cxnSpMkLst>
-        </pc:cxnChg>
-        <pc:cxnChg chg="mod">
-          <ac:chgData name="Tommaso Ghilardi (Staff)" userId="b9591c49-3913-47aa-a516-44e0ea4248a4" providerId="ADAL" clId="{0D36F859-059A-4DB7-AEC5-974ED1AC50D6}" dt="2025-08-29T17:00:49.626" v="310" actId="1076"/>
-          <ac:cxnSpMkLst>
-            <pc:docMk/>
-            <pc:sldMk cId="3385753680" sldId="260"/>
-            <ac:cxnSpMk id="347" creationId="{861F0CE3-0B2A-7E23-9376-9E2C88802F94}"/>
-          </ac:cxnSpMkLst>
-        </pc:cxnChg>
-        <pc:cxnChg chg="mod">
-          <ac:chgData name="Tommaso Ghilardi (Staff)" userId="b9591c49-3913-47aa-a516-44e0ea4248a4" providerId="ADAL" clId="{0D36F859-059A-4DB7-AEC5-974ED1AC50D6}" dt="2025-08-29T17:03:00.198" v="384" actId="1076"/>
-          <ac:cxnSpMkLst>
-            <pc:docMk/>
-            <pc:sldMk cId="3385753680" sldId="260"/>
-            <ac:cxnSpMk id="352" creationId="{CB6E61C5-BC83-A3BD-C4DB-BAC64DD46273}"/>
-          </ac:cxnSpMkLst>
-        </pc:cxnChg>
-        <pc:cxnChg chg="del mod">
-          <ac:chgData name="Tommaso Ghilardi (Staff)" userId="b9591c49-3913-47aa-a516-44e0ea4248a4" providerId="ADAL" clId="{0D36F859-059A-4DB7-AEC5-974ED1AC50D6}" dt="2025-08-29T17:03:21.076" v="389" actId="478"/>
-          <ac:cxnSpMkLst>
-            <pc:docMk/>
-            <pc:sldMk cId="3385753680" sldId="260"/>
-            <ac:cxnSpMk id="370" creationId="{FB3A4D33-5591-4BC0-C6A4-8420EEDF5EE2}"/>
-          </ac:cxnSpMkLst>
-        </pc:cxnChg>
-        <pc:cxnChg chg="del mod">
-          <ac:chgData name="Tommaso Ghilardi (Staff)" userId="b9591c49-3913-47aa-a516-44e0ea4248a4" providerId="ADAL" clId="{0D36F859-059A-4DB7-AEC5-974ED1AC50D6}" dt="2025-08-29T16:56:39.988" v="254" actId="478"/>
-          <ac:cxnSpMkLst>
-            <pc:docMk/>
-            <pc:sldMk cId="3385753680" sldId="260"/>
-            <ac:cxnSpMk id="380" creationId="{C0EDC56A-07D7-E80D-014E-12CF479B2423}"/>
-          </ac:cxnSpMkLst>
-        </pc:cxnChg>
-        <pc:cxnChg chg="del mod">
-          <ac:chgData name="Tommaso Ghilardi (Staff)" userId="b9591c49-3913-47aa-a516-44e0ea4248a4" providerId="ADAL" clId="{0D36F859-059A-4DB7-AEC5-974ED1AC50D6}" dt="2025-08-29T16:56:02.784" v="249" actId="478"/>
-          <ac:cxnSpMkLst>
-            <pc:docMk/>
-            <pc:sldMk cId="3385753680" sldId="260"/>
-            <ac:cxnSpMk id="389" creationId="{0CD123E9-D16A-162A-4B74-E03D8E0A6DD4}"/>
-          </ac:cxnSpMkLst>
-        </pc:cxnChg>
       </pc:sldChg>
     </pc:docChg>
   </pc:docChgLst>
@@ -1025,46 +225,6 @@
           <pc:docMk/>
           <pc:sldMasterMk cId="1786956075" sldId="2147483732"/>
         </pc:sldMasterMkLst>
-        <pc:spChg chg="mod">
-          <ac:chgData name="Tommaso Ghilardi (Staff)" userId="b9591c49-3913-47aa-a516-44e0ea4248a4" providerId="ADAL" clId="{DD8FC568-E9AF-49E1-B5DF-3280526414D3}" dt="2025-06-20T21:15:30.126" v="602"/>
-          <ac:spMkLst>
-            <pc:docMk/>
-            <pc:sldMasterMk cId="1786956075" sldId="2147483732"/>
-            <ac:spMk id="2" creationId="{00000000-0000-0000-0000-000000000000}"/>
-          </ac:spMkLst>
-        </pc:spChg>
-        <pc:spChg chg="mod">
-          <ac:chgData name="Tommaso Ghilardi (Staff)" userId="b9591c49-3913-47aa-a516-44e0ea4248a4" providerId="ADAL" clId="{DD8FC568-E9AF-49E1-B5DF-3280526414D3}" dt="2025-06-20T21:15:30.126" v="602"/>
-          <ac:spMkLst>
-            <pc:docMk/>
-            <pc:sldMasterMk cId="1786956075" sldId="2147483732"/>
-            <ac:spMk id="3" creationId="{00000000-0000-0000-0000-000000000000}"/>
-          </ac:spMkLst>
-        </pc:spChg>
-        <pc:spChg chg="mod">
-          <ac:chgData name="Tommaso Ghilardi (Staff)" userId="b9591c49-3913-47aa-a516-44e0ea4248a4" providerId="ADAL" clId="{DD8FC568-E9AF-49E1-B5DF-3280526414D3}" dt="2025-06-20T21:15:30.126" v="602"/>
-          <ac:spMkLst>
-            <pc:docMk/>
-            <pc:sldMasterMk cId="1786956075" sldId="2147483732"/>
-            <ac:spMk id="4" creationId="{00000000-0000-0000-0000-000000000000}"/>
-          </ac:spMkLst>
-        </pc:spChg>
-        <pc:spChg chg="mod">
-          <ac:chgData name="Tommaso Ghilardi (Staff)" userId="b9591c49-3913-47aa-a516-44e0ea4248a4" providerId="ADAL" clId="{DD8FC568-E9AF-49E1-B5DF-3280526414D3}" dt="2025-06-20T21:15:30.126" v="602"/>
-          <ac:spMkLst>
-            <pc:docMk/>
-            <pc:sldMasterMk cId="1786956075" sldId="2147483732"/>
-            <ac:spMk id="5" creationId="{00000000-0000-0000-0000-000000000000}"/>
-          </ac:spMkLst>
-        </pc:spChg>
-        <pc:spChg chg="mod">
-          <ac:chgData name="Tommaso Ghilardi (Staff)" userId="b9591c49-3913-47aa-a516-44e0ea4248a4" providerId="ADAL" clId="{DD8FC568-E9AF-49E1-B5DF-3280526414D3}" dt="2025-06-20T21:15:30.126" v="602"/>
-          <ac:spMkLst>
-            <pc:docMk/>
-            <pc:sldMasterMk cId="1786956075" sldId="2147483732"/>
-            <ac:spMk id="6" creationId="{00000000-0000-0000-0000-000000000000}"/>
-          </ac:spMkLst>
-        </pc:spChg>
         <pc:sldLayoutChg chg="modSp">
           <pc:chgData name="Tommaso Ghilardi (Staff)" userId="b9591c49-3913-47aa-a516-44e0ea4248a4" providerId="ADAL" clId="{DD8FC568-E9AF-49E1-B5DF-3280526414D3}" dt="2025-06-20T21:15:30.126" v="602"/>
           <pc:sldLayoutMkLst>
@@ -1072,24 +232,6 @@
             <pc:sldMasterMk cId="1786956075" sldId="2147483732"/>
             <pc:sldLayoutMk cId="3397466787" sldId="2147483733"/>
           </pc:sldLayoutMkLst>
-          <pc:spChg chg="mod">
-            <ac:chgData name="Tommaso Ghilardi (Staff)" userId="b9591c49-3913-47aa-a516-44e0ea4248a4" providerId="ADAL" clId="{DD8FC568-E9AF-49E1-B5DF-3280526414D3}" dt="2025-06-20T21:15:30.126" v="602"/>
-            <ac:spMkLst>
-              <pc:docMk/>
-              <pc:sldMasterMk cId="1786956075" sldId="2147483732"/>
-              <pc:sldLayoutMk cId="3397466787" sldId="2147483733"/>
-              <ac:spMk id="2" creationId="{00000000-0000-0000-0000-000000000000}"/>
-            </ac:spMkLst>
-          </pc:spChg>
-          <pc:spChg chg="mod">
-            <ac:chgData name="Tommaso Ghilardi (Staff)" userId="b9591c49-3913-47aa-a516-44e0ea4248a4" providerId="ADAL" clId="{DD8FC568-E9AF-49E1-B5DF-3280526414D3}" dt="2025-06-20T21:15:30.126" v="602"/>
-            <ac:spMkLst>
-              <pc:docMk/>
-              <pc:sldMasterMk cId="1786956075" sldId="2147483732"/>
-              <pc:sldLayoutMk cId="3397466787" sldId="2147483733"/>
-              <ac:spMk id="3" creationId="{00000000-0000-0000-0000-000000000000}"/>
-            </ac:spMkLst>
-          </pc:spChg>
         </pc:sldLayoutChg>
         <pc:sldLayoutChg chg="modSp">
           <pc:chgData name="Tommaso Ghilardi (Staff)" userId="b9591c49-3913-47aa-a516-44e0ea4248a4" providerId="ADAL" clId="{DD8FC568-E9AF-49E1-B5DF-3280526414D3}" dt="2025-06-20T21:15:30.126" v="602"/>
@@ -1098,24 +240,6 @@
             <pc:sldMasterMk cId="1786956075" sldId="2147483732"/>
             <pc:sldLayoutMk cId="1388463586" sldId="2147483735"/>
           </pc:sldLayoutMkLst>
-          <pc:spChg chg="mod">
-            <ac:chgData name="Tommaso Ghilardi (Staff)" userId="b9591c49-3913-47aa-a516-44e0ea4248a4" providerId="ADAL" clId="{DD8FC568-E9AF-49E1-B5DF-3280526414D3}" dt="2025-06-20T21:15:30.126" v="602"/>
-            <ac:spMkLst>
-              <pc:docMk/>
-              <pc:sldMasterMk cId="1786956075" sldId="2147483732"/>
-              <pc:sldLayoutMk cId="1388463586" sldId="2147483735"/>
-              <ac:spMk id="2" creationId="{00000000-0000-0000-0000-000000000000}"/>
-            </ac:spMkLst>
-          </pc:spChg>
-          <pc:spChg chg="mod">
-            <ac:chgData name="Tommaso Ghilardi (Staff)" userId="b9591c49-3913-47aa-a516-44e0ea4248a4" providerId="ADAL" clId="{DD8FC568-E9AF-49E1-B5DF-3280526414D3}" dt="2025-06-20T21:15:30.126" v="602"/>
-            <ac:spMkLst>
-              <pc:docMk/>
-              <pc:sldMasterMk cId="1786956075" sldId="2147483732"/>
-              <pc:sldLayoutMk cId="1388463586" sldId="2147483735"/>
-              <ac:spMk id="3" creationId="{00000000-0000-0000-0000-000000000000}"/>
-            </ac:spMkLst>
-          </pc:spChg>
         </pc:sldLayoutChg>
         <pc:sldLayoutChg chg="modSp">
           <pc:chgData name="Tommaso Ghilardi (Staff)" userId="b9591c49-3913-47aa-a516-44e0ea4248a4" providerId="ADAL" clId="{DD8FC568-E9AF-49E1-B5DF-3280526414D3}" dt="2025-06-20T21:15:30.126" v="602"/>
@@ -1124,24 +248,6 @@
             <pc:sldMasterMk cId="1786956075" sldId="2147483732"/>
             <pc:sldLayoutMk cId="4058901221" sldId="2147483736"/>
           </pc:sldLayoutMkLst>
-          <pc:spChg chg="mod">
-            <ac:chgData name="Tommaso Ghilardi (Staff)" userId="b9591c49-3913-47aa-a516-44e0ea4248a4" providerId="ADAL" clId="{DD8FC568-E9AF-49E1-B5DF-3280526414D3}" dt="2025-06-20T21:15:30.126" v="602"/>
-            <ac:spMkLst>
-              <pc:docMk/>
-              <pc:sldMasterMk cId="1786956075" sldId="2147483732"/>
-              <pc:sldLayoutMk cId="4058901221" sldId="2147483736"/>
-              <ac:spMk id="3" creationId="{00000000-0000-0000-0000-000000000000}"/>
-            </ac:spMkLst>
-          </pc:spChg>
-          <pc:spChg chg="mod">
-            <ac:chgData name="Tommaso Ghilardi (Staff)" userId="b9591c49-3913-47aa-a516-44e0ea4248a4" providerId="ADAL" clId="{DD8FC568-E9AF-49E1-B5DF-3280526414D3}" dt="2025-06-20T21:15:30.126" v="602"/>
-            <ac:spMkLst>
-              <pc:docMk/>
-              <pc:sldMasterMk cId="1786956075" sldId="2147483732"/>
-              <pc:sldLayoutMk cId="4058901221" sldId="2147483736"/>
-              <ac:spMk id="4" creationId="{00000000-0000-0000-0000-000000000000}"/>
-            </ac:spMkLst>
-          </pc:spChg>
         </pc:sldLayoutChg>
         <pc:sldLayoutChg chg="modSp">
           <pc:chgData name="Tommaso Ghilardi (Staff)" userId="b9591c49-3913-47aa-a516-44e0ea4248a4" providerId="ADAL" clId="{DD8FC568-E9AF-49E1-B5DF-3280526414D3}" dt="2025-06-20T21:15:30.126" v="602"/>
@@ -1150,51 +256,6 @@
             <pc:sldMasterMk cId="1786956075" sldId="2147483732"/>
             <pc:sldLayoutMk cId="2797219153" sldId="2147483737"/>
           </pc:sldLayoutMkLst>
-          <pc:spChg chg="mod">
-            <ac:chgData name="Tommaso Ghilardi (Staff)" userId="b9591c49-3913-47aa-a516-44e0ea4248a4" providerId="ADAL" clId="{DD8FC568-E9AF-49E1-B5DF-3280526414D3}" dt="2025-06-20T21:15:30.126" v="602"/>
-            <ac:spMkLst>
-              <pc:docMk/>
-              <pc:sldMasterMk cId="1786956075" sldId="2147483732"/>
-              <pc:sldLayoutMk cId="2797219153" sldId="2147483737"/>
-              <ac:spMk id="2" creationId="{00000000-0000-0000-0000-000000000000}"/>
-            </ac:spMkLst>
-          </pc:spChg>
-          <pc:spChg chg="mod">
-            <ac:chgData name="Tommaso Ghilardi (Staff)" userId="b9591c49-3913-47aa-a516-44e0ea4248a4" providerId="ADAL" clId="{DD8FC568-E9AF-49E1-B5DF-3280526414D3}" dt="2025-06-20T21:15:30.126" v="602"/>
-            <ac:spMkLst>
-              <pc:docMk/>
-              <pc:sldMasterMk cId="1786956075" sldId="2147483732"/>
-              <pc:sldLayoutMk cId="2797219153" sldId="2147483737"/>
-              <ac:spMk id="3" creationId="{00000000-0000-0000-0000-000000000000}"/>
-            </ac:spMkLst>
-          </pc:spChg>
-          <pc:spChg chg="mod">
-            <ac:chgData name="Tommaso Ghilardi (Staff)" userId="b9591c49-3913-47aa-a516-44e0ea4248a4" providerId="ADAL" clId="{DD8FC568-E9AF-49E1-B5DF-3280526414D3}" dt="2025-06-20T21:15:30.126" v="602"/>
-            <ac:spMkLst>
-              <pc:docMk/>
-              <pc:sldMasterMk cId="1786956075" sldId="2147483732"/>
-              <pc:sldLayoutMk cId="2797219153" sldId="2147483737"/>
-              <ac:spMk id="4" creationId="{00000000-0000-0000-0000-000000000000}"/>
-            </ac:spMkLst>
-          </pc:spChg>
-          <pc:spChg chg="mod">
-            <ac:chgData name="Tommaso Ghilardi (Staff)" userId="b9591c49-3913-47aa-a516-44e0ea4248a4" providerId="ADAL" clId="{DD8FC568-E9AF-49E1-B5DF-3280526414D3}" dt="2025-06-20T21:15:30.126" v="602"/>
-            <ac:spMkLst>
-              <pc:docMk/>
-              <pc:sldMasterMk cId="1786956075" sldId="2147483732"/>
-              <pc:sldLayoutMk cId="2797219153" sldId="2147483737"/>
-              <ac:spMk id="5" creationId="{00000000-0000-0000-0000-000000000000}"/>
-            </ac:spMkLst>
-          </pc:spChg>
-          <pc:spChg chg="mod">
-            <ac:chgData name="Tommaso Ghilardi (Staff)" userId="b9591c49-3913-47aa-a516-44e0ea4248a4" providerId="ADAL" clId="{DD8FC568-E9AF-49E1-B5DF-3280526414D3}" dt="2025-06-20T21:15:30.126" v="602"/>
-            <ac:spMkLst>
-              <pc:docMk/>
-              <pc:sldMasterMk cId="1786956075" sldId="2147483732"/>
-              <pc:sldLayoutMk cId="2797219153" sldId="2147483737"/>
-              <ac:spMk id="6" creationId="{00000000-0000-0000-0000-000000000000}"/>
-            </ac:spMkLst>
-          </pc:spChg>
         </pc:sldLayoutChg>
         <pc:sldLayoutChg chg="modSp">
           <pc:chgData name="Tommaso Ghilardi (Staff)" userId="b9591c49-3913-47aa-a516-44e0ea4248a4" providerId="ADAL" clId="{DD8FC568-E9AF-49E1-B5DF-3280526414D3}" dt="2025-06-20T21:15:30.126" v="602"/>
@@ -1203,33 +264,6 @@
             <pc:sldMasterMk cId="1786956075" sldId="2147483732"/>
             <pc:sldLayoutMk cId="2744220517" sldId="2147483740"/>
           </pc:sldLayoutMkLst>
-          <pc:spChg chg="mod">
-            <ac:chgData name="Tommaso Ghilardi (Staff)" userId="b9591c49-3913-47aa-a516-44e0ea4248a4" providerId="ADAL" clId="{DD8FC568-E9AF-49E1-B5DF-3280526414D3}" dt="2025-06-20T21:15:30.126" v="602"/>
-            <ac:spMkLst>
-              <pc:docMk/>
-              <pc:sldMasterMk cId="1786956075" sldId="2147483732"/>
-              <pc:sldLayoutMk cId="2744220517" sldId="2147483740"/>
-              <ac:spMk id="2" creationId="{00000000-0000-0000-0000-000000000000}"/>
-            </ac:spMkLst>
-          </pc:spChg>
-          <pc:spChg chg="mod">
-            <ac:chgData name="Tommaso Ghilardi (Staff)" userId="b9591c49-3913-47aa-a516-44e0ea4248a4" providerId="ADAL" clId="{DD8FC568-E9AF-49E1-B5DF-3280526414D3}" dt="2025-06-20T21:15:30.126" v="602"/>
-            <ac:spMkLst>
-              <pc:docMk/>
-              <pc:sldMasterMk cId="1786956075" sldId="2147483732"/>
-              <pc:sldLayoutMk cId="2744220517" sldId="2147483740"/>
-              <ac:spMk id="3" creationId="{00000000-0000-0000-0000-000000000000}"/>
-            </ac:spMkLst>
-          </pc:spChg>
-          <pc:spChg chg="mod">
-            <ac:chgData name="Tommaso Ghilardi (Staff)" userId="b9591c49-3913-47aa-a516-44e0ea4248a4" providerId="ADAL" clId="{DD8FC568-E9AF-49E1-B5DF-3280526414D3}" dt="2025-06-20T21:15:30.126" v="602"/>
-            <ac:spMkLst>
-              <pc:docMk/>
-              <pc:sldMasterMk cId="1786956075" sldId="2147483732"/>
-              <pc:sldLayoutMk cId="2744220517" sldId="2147483740"/>
-              <ac:spMk id="4" creationId="{00000000-0000-0000-0000-000000000000}"/>
-            </ac:spMkLst>
-          </pc:spChg>
         </pc:sldLayoutChg>
         <pc:sldLayoutChg chg="modSp">
           <pc:chgData name="Tommaso Ghilardi (Staff)" userId="b9591c49-3913-47aa-a516-44e0ea4248a4" providerId="ADAL" clId="{DD8FC568-E9AF-49E1-B5DF-3280526414D3}" dt="2025-06-20T21:15:30.126" v="602"/>
@@ -1238,33 +272,6 @@
             <pc:sldMasterMk cId="1786956075" sldId="2147483732"/>
             <pc:sldLayoutMk cId="3653992267" sldId="2147483741"/>
           </pc:sldLayoutMkLst>
-          <pc:spChg chg="mod">
-            <ac:chgData name="Tommaso Ghilardi (Staff)" userId="b9591c49-3913-47aa-a516-44e0ea4248a4" providerId="ADAL" clId="{DD8FC568-E9AF-49E1-B5DF-3280526414D3}" dt="2025-06-20T21:15:30.126" v="602"/>
-            <ac:spMkLst>
-              <pc:docMk/>
-              <pc:sldMasterMk cId="1786956075" sldId="2147483732"/>
-              <pc:sldLayoutMk cId="3653992267" sldId="2147483741"/>
-              <ac:spMk id="2" creationId="{00000000-0000-0000-0000-000000000000}"/>
-            </ac:spMkLst>
-          </pc:spChg>
-          <pc:spChg chg="mod">
-            <ac:chgData name="Tommaso Ghilardi (Staff)" userId="b9591c49-3913-47aa-a516-44e0ea4248a4" providerId="ADAL" clId="{DD8FC568-E9AF-49E1-B5DF-3280526414D3}" dt="2025-06-20T21:15:30.126" v="602"/>
-            <ac:spMkLst>
-              <pc:docMk/>
-              <pc:sldMasterMk cId="1786956075" sldId="2147483732"/>
-              <pc:sldLayoutMk cId="3653992267" sldId="2147483741"/>
-              <ac:spMk id="3" creationId="{00000000-0000-0000-0000-000000000000}"/>
-            </ac:spMkLst>
-          </pc:spChg>
-          <pc:spChg chg="mod">
-            <ac:chgData name="Tommaso Ghilardi (Staff)" userId="b9591c49-3913-47aa-a516-44e0ea4248a4" providerId="ADAL" clId="{DD8FC568-E9AF-49E1-B5DF-3280526414D3}" dt="2025-06-20T21:15:30.126" v="602"/>
-            <ac:spMkLst>
-              <pc:docMk/>
-              <pc:sldMasterMk cId="1786956075" sldId="2147483732"/>
-              <pc:sldLayoutMk cId="3653992267" sldId="2147483741"/>
-              <ac:spMk id="4" creationId="{00000000-0000-0000-0000-000000000000}"/>
-            </ac:spMkLst>
-          </pc:spChg>
         </pc:sldLayoutChg>
         <pc:sldLayoutChg chg="modSp">
           <pc:chgData name="Tommaso Ghilardi (Staff)" userId="b9591c49-3913-47aa-a516-44e0ea4248a4" providerId="ADAL" clId="{DD8FC568-E9AF-49E1-B5DF-3280526414D3}" dt="2025-06-20T21:15:30.126" v="602"/>
@@ -1273,24 +280,6 @@
             <pc:sldMasterMk cId="1786956075" sldId="2147483732"/>
             <pc:sldLayoutMk cId="67552525" sldId="2147483743"/>
           </pc:sldLayoutMkLst>
-          <pc:spChg chg="mod">
-            <ac:chgData name="Tommaso Ghilardi (Staff)" userId="b9591c49-3913-47aa-a516-44e0ea4248a4" providerId="ADAL" clId="{DD8FC568-E9AF-49E1-B5DF-3280526414D3}" dt="2025-06-20T21:15:30.126" v="602"/>
-            <ac:spMkLst>
-              <pc:docMk/>
-              <pc:sldMasterMk cId="1786956075" sldId="2147483732"/>
-              <pc:sldLayoutMk cId="67552525" sldId="2147483743"/>
-              <ac:spMk id="2" creationId="{00000000-0000-0000-0000-000000000000}"/>
-            </ac:spMkLst>
-          </pc:spChg>
-          <pc:spChg chg="mod">
-            <ac:chgData name="Tommaso Ghilardi (Staff)" userId="b9591c49-3913-47aa-a516-44e0ea4248a4" providerId="ADAL" clId="{DD8FC568-E9AF-49E1-B5DF-3280526414D3}" dt="2025-06-20T21:15:30.126" v="602"/>
-            <ac:spMkLst>
-              <pc:docMk/>
-              <pc:sldMasterMk cId="1786956075" sldId="2147483732"/>
-              <pc:sldLayoutMk cId="67552525" sldId="2147483743"/>
-              <ac:spMk id="3" creationId="{00000000-0000-0000-0000-000000000000}"/>
-            </ac:spMkLst>
-          </pc:spChg>
         </pc:sldLayoutChg>
       </pc:sldMasterChg>
       <pc:sldMasterChg chg="modSp modSldLayout">
@@ -1492,7 +481,7 @@
           <a:p>
             <a:fld id="{846CE7D5-CF57-46EF-B807-FDD0502418D4}" type="datetimeFigureOut">
               <a:rPr lang="en-GB" smtClean="0"/>
-              <a:t>30/08/2025</a:t>
+              <a:t>06/11/2025</a:t>
             </a:fld>
             <a:endParaRPr lang="en-GB"/>
           </a:p>
@@ -1662,7 +651,7 @@
           <a:p>
             <a:fld id="{846CE7D5-CF57-46EF-B807-FDD0502418D4}" type="datetimeFigureOut">
               <a:rPr lang="en-GB" smtClean="0"/>
-              <a:t>30/08/2025</a:t>
+              <a:t>06/11/2025</a:t>
             </a:fld>
             <a:endParaRPr lang="en-GB"/>
           </a:p>
@@ -1842,7 +831,7 @@
           <a:p>
             <a:fld id="{846CE7D5-CF57-46EF-B807-FDD0502418D4}" type="datetimeFigureOut">
               <a:rPr lang="en-GB" smtClean="0"/>
-              <a:t>30/08/2025</a:t>
+              <a:t>06/11/2025</a:t>
             </a:fld>
             <a:endParaRPr lang="en-GB"/>
           </a:p>
@@ -2012,7 +1001,7 @@
           <a:p>
             <a:fld id="{846CE7D5-CF57-46EF-B807-FDD0502418D4}" type="datetimeFigureOut">
               <a:rPr lang="en-GB" smtClean="0"/>
-              <a:t>30/08/2025</a:t>
+              <a:t>06/11/2025</a:t>
             </a:fld>
             <a:endParaRPr lang="en-GB"/>
           </a:p>
@@ -2258,7 +1247,7 @@
           <a:p>
             <a:fld id="{846CE7D5-CF57-46EF-B807-FDD0502418D4}" type="datetimeFigureOut">
               <a:rPr lang="en-GB" smtClean="0"/>
-              <a:t>30/08/2025</a:t>
+              <a:t>06/11/2025</a:t>
             </a:fld>
             <a:endParaRPr lang="en-GB"/>
           </a:p>
@@ -2490,7 +1479,7 @@
           <a:p>
             <a:fld id="{846CE7D5-CF57-46EF-B807-FDD0502418D4}" type="datetimeFigureOut">
               <a:rPr lang="en-GB" smtClean="0"/>
-              <a:t>30/08/2025</a:t>
+              <a:t>06/11/2025</a:t>
             </a:fld>
             <a:endParaRPr lang="en-GB"/>
           </a:p>
@@ -2857,7 +1846,7 @@
           <a:p>
             <a:fld id="{846CE7D5-CF57-46EF-B807-FDD0502418D4}" type="datetimeFigureOut">
               <a:rPr lang="en-GB" smtClean="0"/>
-              <a:t>30/08/2025</a:t>
+              <a:t>06/11/2025</a:t>
             </a:fld>
             <a:endParaRPr lang="en-GB"/>
           </a:p>
@@ -2975,7 +1964,7 @@
           <a:p>
             <a:fld id="{846CE7D5-CF57-46EF-B807-FDD0502418D4}" type="datetimeFigureOut">
               <a:rPr lang="en-GB" smtClean="0"/>
-              <a:t>30/08/2025</a:t>
+              <a:t>06/11/2025</a:t>
             </a:fld>
             <a:endParaRPr lang="en-GB"/>
           </a:p>
@@ -3070,7 +2059,7 @@
           <a:p>
             <a:fld id="{846CE7D5-CF57-46EF-B807-FDD0502418D4}" type="datetimeFigureOut">
               <a:rPr lang="en-GB" smtClean="0"/>
-              <a:t>30/08/2025</a:t>
+              <a:t>06/11/2025</a:t>
             </a:fld>
             <a:endParaRPr lang="en-GB"/>
           </a:p>
@@ -3347,7 +2336,7 @@
           <a:p>
             <a:fld id="{846CE7D5-CF57-46EF-B807-FDD0502418D4}" type="datetimeFigureOut">
               <a:rPr lang="en-GB" smtClean="0"/>
-              <a:t>30/08/2025</a:t>
+              <a:t>06/11/2025</a:t>
             </a:fld>
             <a:endParaRPr lang="en-GB"/>
           </a:p>
@@ -3604,7 +2593,7 @@
           <a:p>
             <a:fld id="{846CE7D5-CF57-46EF-B807-FDD0502418D4}" type="datetimeFigureOut">
               <a:rPr lang="en-GB" smtClean="0"/>
-              <a:t>30/08/2025</a:t>
+              <a:t>06/11/2025</a:t>
             </a:fld>
             <a:endParaRPr lang="en-GB"/>
           </a:p>
@@ -3817,7 +2806,7 @@
           <a:p>
             <a:fld id="{846CE7D5-CF57-46EF-B807-FDD0502418D4}" type="datetimeFigureOut">
               <a:rPr lang="en-GB" smtClean="0"/>
-              <a:t>30/08/2025</a:t>
+              <a:t>06/11/2025</a:t>
             </a:fld>
             <a:endParaRPr lang="en-GB"/>
           </a:p>
@@ -11853,7 +10842,7 @@
       <p:sp>
         <p:nvSpPr>
           <p:cNvPr id="3" name="Rectangle: Rounded Corners 2">
-            <a:hlinkClick r:id="rId8"/>
+            <a:hlinkClick r:id="rId17"/>
             <a:extLst>
               <a:ext uri="{FF2B5EF4-FFF2-40B4-BE49-F238E27FC236}">
                 <a16:creationId xmlns:a16="http://schemas.microsoft.com/office/drawing/2014/main" id="{5A05495E-9357-E471-D091-454DB08C8488}"/>
@@ -12509,8 +11498,25 @@
                 <a:latin typeface="Arial" panose="020B0604020202020204" pitchFamily="34" charset="0"/>
                 <a:cs typeface="Arial" panose="020B0604020202020204" pitchFamily="34" charset="0"/>
               </a:rPr>
-              <a:t>You will need an IDE, we recommend Spyder</a:t>
+              <a:t>You will need an IDE, we </a:t>
             </a:r>
+            <a:r>
+              <a:rPr lang="en-GB">
+                <a:solidFill>
+                  <a:sysClr val="windowText" lastClr="000000"/>
+                </a:solidFill>
+                <a:latin typeface="Arial" panose="020B0604020202020204" pitchFamily="34" charset="0"/>
+                <a:cs typeface="Arial" panose="020B0604020202020204" pitchFamily="34" charset="0"/>
+              </a:rPr>
+              <a:t>recommend Positron</a:t>
+            </a:r>
+            <a:endParaRPr lang="en-GB" dirty="0">
+              <a:solidFill>
+                <a:sysClr val="windowText" lastClr="000000"/>
+              </a:solidFill>
+              <a:latin typeface="Arial" panose="020B0604020202020204" pitchFamily="34" charset="0"/>
+              <a:cs typeface="Arial" panose="020B0604020202020204" pitchFamily="34" charset="0"/>
+            </a:endParaRPr>
           </a:p>
         </p:txBody>
       </p:sp>
@@ -12617,10 +11623,10 @@
           <p:nvPr/>
         </p:nvPicPr>
         <p:blipFill>
-          <a:blip r:embed="rId17">
+          <a:blip r:embed="rId18">
             <a:extLst>
               <a:ext uri="{96DAC541-7B7A-43D3-8B79-37D633B846F1}">
-                <asvg:svgBlip xmlns:asvg="http://schemas.microsoft.com/office/drawing/2016/SVG/main" r:embed="rId18"/>
+                <asvg:svgBlip xmlns:asvg="http://schemas.microsoft.com/office/drawing/2016/SVG/main" r:embed="rId19"/>
               </a:ext>
             </a:extLst>
           </a:blip>
@@ -12653,10 +11659,10 @@
           <p:nvPr/>
         </p:nvPicPr>
         <p:blipFill>
-          <a:blip r:embed="rId17">
+          <a:blip r:embed="rId18">
             <a:extLst>
               <a:ext uri="{96DAC541-7B7A-43D3-8B79-37D633B846F1}">
-                <asvg:svgBlip xmlns:asvg="http://schemas.microsoft.com/office/drawing/2016/SVG/main" r:embed="rId18"/>
+                <asvg:svgBlip xmlns:asvg="http://schemas.microsoft.com/office/drawing/2016/SVG/main" r:embed="rId19"/>
               </a:ext>
             </a:extLst>
           </a:blip>
@@ -12689,10 +11695,10 @@
           <p:nvPr/>
         </p:nvPicPr>
         <p:blipFill>
-          <a:blip r:embed="rId17">
+          <a:blip r:embed="rId18">
             <a:extLst>
               <a:ext uri="{96DAC541-7B7A-43D3-8B79-37D633B846F1}">
-                <asvg:svgBlip xmlns:asvg="http://schemas.microsoft.com/office/drawing/2016/SVG/main" r:embed="rId18"/>
+                <asvg:svgBlip xmlns:asvg="http://schemas.microsoft.com/office/drawing/2016/SVG/main" r:embed="rId19"/>
               </a:ext>
             </a:extLst>
           </a:blip>
@@ -12725,10 +11731,10 @@
           <p:nvPr/>
         </p:nvPicPr>
         <p:blipFill>
-          <a:blip r:embed="rId17">
+          <a:blip r:embed="rId18">
             <a:extLst>
               <a:ext uri="{96DAC541-7B7A-43D3-8B79-37D633B846F1}">
-                <asvg:svgBlip xmlns:asvg="http://schemas.microsoft.com/office/drawing/2016/SVG/main" r:embed="rId18"/>
+                <asvg:svgBlip xmlns:asvg="http://schemas.microsoft.com/office/drawing/2016/SVG/main" r:embed="rId19"/>
               </a:ext>
             </a:extLst>
           </a:blip>
@@ -12761,10 +11767,10 @@
           <p:nvPr/>
         </p:nvPicPr>
         <p:blipFill>
-          <a:blip r:embed="rId17">
+          <a:blip r:embed="rId18">
             <a:extLst>
               <a:ext uri="{96DAC541-7B7A-43D3-8B79-37D633B846F1}">
-                <asvg:svgBlip xmlns:asvg="http://schemas.microsoft.com/office/drawing/2016/SVG/main" r:embed="rId18"/>
+                <asvg:svgBlip xmlns:asvg="http://schemas.microsoft.com/office/drawing/2016/SVG/main" r:embed="rId19"/>
               </a:ext>
             </a:extLst>
           </a:blip>
@@ -12785,7 +11791,7 @@
       <p:sp>
         <p:nvSpPr>
           <p:cNvPr id="363" name="Rectangle: Rounded Corners 362">
-            <a:hlinkClick r:id="rId19"/>
+            <a:hlinkClick r:id="rId20"/>
             <a:extLst>
               <a:ext uri="{FF2B5EF4-FFF2-40B4-BE49-F238E27FC236}">
                 <a16:creationId xmlns:a16="http://schemas.microsoft.com/office/drawing/2014/main" id="{2E5DDD62-31D5-DB35-7882-69ED9834C436}"/>
@@ -13096,7 +12102,7 @@
       <p:sp>
         <p:nvSpPr>
           <p:cNvPr id="30" name="Rectangle: Rounded Corners 29">
-            <a:hlinkClick r:id="rId20"/>
+            <a:hlinkClick r:id="rId21"/>
             <a:extLst>
               <a:ext uri="{FF2B5EF4-FFF2-40B4-BE49-F238E27FC236}">
                 <a16:creationId xmlns:a16="http://schemas.microsoft.com/office/drawing/2014/main" id="{84017305-8577-D1BA-26A3-76934F4A6EC4}"/>
@@ -13986,7 +12992,7 @@
       <p:sp>
         <p:nvSpPr>
           <p:cNvPr id="15" name="Rectangle: Rounded Corners 14">
-            <a:hlinkClick r:id="rId21"/>
+            <a:hlinkClick r:id="rId22"/>
             <a:extLst>
               <a:ext uri="{FF2B5EF4-FFF2-40B4-BE49-F238E27FC236}">
                 <a16:creationId xmlns:a16="http://schemas.microsoft.com/office/drawing/2014/main" id="{05A170F7-4CA5-62FF-3898-7B1B95B0C649}"/>
@@ -14370,7 +13376,7 @@
           <p:nvPr/>
         </p:nvPicPr>
         <p:blipFill>
-          <a:blip r:embed="rId22">
+          <a:blip r:embed="rId23">
             <a:extLst>
               <a:ext uri="{28A0092B-C50C-407E-A947-70E740481C1C}">
                 <a14:useLocalDpi xmlns:a14="http://schemas.microsoft.com/office/drawing/2010/main" val="0"/>
@@ -14406,7 +13412,7 @@
           <p:nvPr/>
         </p:nvPicPr>
         <p:blipFill>
-          <a:blip r:embed="rId23">
+          <a:blip r:embed="rId24">
             <a:extLst>
               <a:ext uri="{28A0092B-C50C-407E-A947-70E740481C1C}">
                 <a14:useLocalDpi xmlns:a14="http://schemas.microsoft.com/office/drawing/2010/main" val="0"/>
@@ -14430,7 +13436,7 @@
       <p:sp>
         <p:nvSpPr>
           <p:cNvPr id="2" name="Rectangle: Rounded Corners 1">
-            <a:hlinkClick r:id="rId24"/>
+            <a:hlinkClick r:id="rId25"/>
             <a:extLst>
               <a:ext uri="{FF2B5EF4-FFF2-40B4-BE49-F238E27FC236}">
                 <a16:creationId xmlns:a16="http://schemas.microsoft.com/office/drawing/2014/main" id="{51ECF505-A488-5A1A-87F2-9AE71DFD7584}"/>

</xml_diff>